<commit_message>
docs: add cover page to the system intro deck
Prepend a cover slide/page (title, subtitle, tagline, tech-stack line) to
both the PPTX and PDF; the three content pages keep their 1/3–3/3 labels.

Co-Authored-By: Claude Opus 4.8 (1M context) <noreply@anthropic.com>
</commit_message>
<xml_diff>
--- a/docs/arxivLens-系統介紹.pptx
+++ b/docs/arxivLens-系統介紹.pptx
@@ -8,6 +8,7 @@
     <p:sldId id="256" r:id="rId7"/>
     <p:sldId id="257" r:id="rId8"/>
     <p:sldId id="258" r:id="rId9"/>
+    <p:sldId id="259" r:id="rId10"/>
   </p:sldIdLst>
   <p:sldSz cx="12191695" cy="6858000" type="screen4x3"/>
   <p:notesSz cx="6858000" cy="9144000"/>
@@ -3142,8 +3143,8 @@
         </p:nvSpPr>
         <p:spPr>
           <a:xfrm>
-            <a:off x="548640" y="502920"/>
-            <a:ext cx="109728" cy="566928"/>
+            <a:off x="868680" y="2286000"/>
+            <a:ext cx="164592" cy="1828800"/>
           </a:xfrm>
           <a:prstGeom prst="rect">
             <a:avLst/>
@@ -3186,8 +3187,8 @@
         </p:nvSpPr>
         <p:spPr>
           <a:xfrm>
-            <a:off x="777240" y="411480"/>
-            <a:ext cx="9601200" cy="914400"/>
+            <a:off x="1188720" y="2148840"/>
+            <a:ext cx="10241280" cy="1097280"/>
           </a:xfrm>
           <a:prstGeom prst="rect">
             <a:avLst/>
@@ -3212,7 +3213,7 @@
               </a:spcAft>
             </a:pPr>
             <a:r>
-              <a:rPr sz="2600" b="1">
+              <a:rPr sz="5400" b="1">
                 <a:solidFill>
                   <a:srgbClr val="18181B"/>
                 </a:solidFill>
@@ -3220,18 +3221,7 @@
                 <a:ea typeface="Microsoft JhengHei"/>
                 <a:cs typeface="Microsoft JhengHei"/>
               </a:rPr>
-              <a:t>系統架構  </a:t>
-            </a:r>
-            <a:r>
-              <a:rPr sz="1500" b="0">
-                <a:solidFill>
-                  <a:srgbClr val="71717A"/>
-                </a:solidFill>
-                <a:latin typeface="Microsoft JhengHei"/>
-                <a:ea typeface="Microsoft JhengHei"/>
-                <a:cs typeface="Microsoft JhengHei"/>
-              </a:rPr>
-              <a:t>System Architecture</a:t>
+              <a:t>arxivLens</a:t>
             </a:r>
           </a:p>
         </p:txBody>
@@ -3244,8 +3234,204 @@
         </p:nvSpPr>
         <p:spPr>
           <a:xfrm>
-            <a:off x="10972800" y="457200"/>
-            <a:ext cx="822960" cy="548640"/>
+            <a:off x="1225296" y="3291840"/>
+            <a:ext cx="10241280" cy="640080"/>
+          </a:xfrm>
+          <a:prstGeom prst="rect">
+            <a:avLst/>
+          </a:prstGeom>
+          <a:noFill/>
+        </p:spPr>
+        <p:txBody>
+          <a:bodyPr wrap="square" anchor="t">
+            <a:spAutoFit/>
+          </a:bodyPr>
+          <a:lstStyle/>
+          <a:p>
+            <a:pPr algn="l">
+              <a:lnSpc>
+                <a:spcPct val="105000"/>
+              </a:lnSpc>
+              <a:spcBef>
+                <a:spcPts val="0"/>
+              </a:spcBef>
+              <a:spcAft>
+                <a:spcPts val="200"/>
+              </a:spcAft>
+            </a:pPr>
+            <a:r>
+              <a:rPr sz="2400" b="1">
+                <a:solidFill>
+                  <a:srgbClr val="2563EB"/>
+                </a:solidFill>
+                <a:latin typeface="Microsoft JhengHei"/>
+                <a:ea typeface="Microsoft JhengHei"/>
+                <a:cs typeface="Microsoft JhengHei"/>
+              </a:rPr>
+              <a:t>系統介紹   </a:t>
+            </a:r>
+            <a:r>
+              <a:rPr sz="1800" b="0">
+                <a:solidFill>
+                  <a:srgbClr val="71717A"/>
+                </a:solidFill>
+                <a:latin typeface="Microsoft JhengHei"/>
+                <a:ea typeface="Microsoft JhengHei"/>
+                <a:cs typeface="Microsoft JhengHei"/>
+              </a:rPr>
+              <a:t>System Introduction</a:t>
+            </a:r>
+          </a:p>
+        </p:txBody>
+      </p:sp>
+      <p:sp>
+        <p:nvSpPr>
+          <p:cNvPr id="6" name="TextBox 5"/>
+          <p:cNvSpPr txBox="1"/>
+          <p:nvPr/>
+        </p:nvSpPr>
+        <p:spPr>
+          <a:xfrm>
+            <a:off x="1225296" y="4114800"/>
+            <a:ext cx="10241280" cy="548640"/>
+          </a:xfrm>
+          <a:prstGeom prst="rect">
+            <a:avLst/>
+          </a:prstGeom>
+          <a:noFill/>
+        </p:spPr>
+        <p:txBody>
+          <a:bodyPr wrap="square" anchor="t">
+            <a:spAutoFit/>
+          </a:bodyPr>
+          <a:lstStyle/>
+          <a:p>
+            <a:pPr algn="l">
+              <a:lnSpc>
+                <a:spcPct val="105000"/>
+              </a:lnSpc>
+              <a:spcBef>
+                <a:spcPts val="0"/>
+              </a:spcBef>
+              <a:spcAft>
+                <a:spcPts val="200"/>
+              </a:spcAft>
+            </a:pPr>
+            <a:r>
+              <a:rPr sz="1500" b="0">
+                <a:solidFill>
+                  <a:srgbClr val="18181B"/>
+                </a:solidFill>
+                <a:latin typeface="Microsoft JhengHei"/>
+                <a:ea typeface="Microsoft JhengHei"/>
+                <a:cs typeface="Microsoft JhengHei"/>
+              </a:rPr>
+              <a:t>arXiv / HBR 論文聚合閱讀器 — AI 摘要、關鍵字評分、多語翻譯</a:t>
+            </a:r>
+          </a:p>
+        </p:txBody>
+      </p:sp>
+      <p:sp>
+        <p:nvSpPr>
+          <p:cNvPr id="7" name="Rectangle 6"/>
+          <p:cNvSpPr/>
+          <p:nvPr/>
+        </p:nvSpPr>
+        <p:spPr>
+          <a:xfrm>
+            <a:off x="1225296" y="5532120"/>
+            <a:ext cx="9692640" cy="12801"/>
+          </a:xfrm>
+          <a:prstGeom prst="rect">
+            <a:avLst/>
+          </a:prstGeom>
+          <a:solidFill>
+            <a:srgbClr val="E4E4E7"/>
+          </a:solidFill>
+          <a:ln>
+            <a:noFill/>
+          </a:ln>
+          <a:effectLst/>
+        </p:spPr>
+        <p:style>
+          <a:lnRef idx="1">
+            <a:schemeClr val="accent1"/>
+          </a:lnRef>
+          <a:fillRef idx="3">
+            <a:schemeClr val="accent1"/>
+          </a:fillRef>
+          <a:effectRef idx="2">
+            <a:schemeClr val="accent1"/>
+          </a:effectRef>
+          <a:fontRef idx="minor">
+            <a:schemeClr val="lt1"/>
+          </a:fontRef>
+        </p:style>
+        <p:txBody>
+          <a:bodyPr rtlCol="0" anchor="ctr"/>
+          <a:lstStyle/>
+          <a:p>
+            <a:pPr algn="ctr"/>
+          </a:p>
+        </p:txBody>
+      </p:sp>
+      <p:sp>
+        <p:nvSpPr>
+          <p:cNvPr id="8" name="TextBox 7"/>
+          <p:cNvSpPr txBox="1"/>
+          <p:nvPr/>
+        </p:nvSpPr>
+        <p:spPr>
+          <a:xfrm>
+            <a:off x="1225296" y="5669280"/>
+            <a:ext cx="10241280" cy="457200"/>
+          </a:xfrm>
+          <a:prstGeom prst="rect">
+            <a:avLst/>
+          </a:prstGeom>
+          <a:noFill/>
+        </p:spPr>
+        <p:txBody>
+          <a:bodyPr wrap="square" anchor="t">
+            <a:spAutoFit/>
+          </a:bodyPr>
+          <a:lstStyle/>
+          <a:p>
+            <a:pPr algn="l">
+              <a:lnSpc>
+                <a:spcPct val="105000"/>
+              </a:lnSpc>
+              <a:spcBef>
+                <a:spcPts val="0"/>
+              </a:spcBef>
+              <a:spcAft>
+                <a:spcPts val="200"/>
+              </a:spcAft>
+            </a:pPr>
+            <a:r>
+              <a:rPr sz="1200" b="0">
+                <a:solidFill>
+                  <a:srgbClr val="71717A"/>
+                </a:solidFill>
+                <a:latin typeface="Microsoft JhengHei"/>
+                <a:ea typeface="Microsoft JhengHei"/>
+                <a:cs typeface="Microsoft JhengHei"/>
+              </a:rPr>
+              <a:t>Next.js 16 · React 19 · Spring Boot 4 · Java 25 · TiDB Cloud · Google Gemini 2.5 Flash</a:t>
+            </a:r>
+          </a:p>
+        </p:txBody>
+      </p:sp>
+      <p:sp>
+        <p:nvSpPr>
+          <p:cNvPr id="9" name="TextBox 8"/>
+          <p:cNvSpPr txBox="1"/>
+          <p:nvPr/>
+        </p:nvSpPr>
+        <p:spPr>
+          <a:xfrm>
+            <a:off x="9692640" y="640080"/>
+            <a:ext cx="1920240" cy="365760"/>
           </a:xfrm>
           <a:prstGeom prst="rect">
             <a:avLst/>
@@ -3278,1263 +3464,7 @@
                 <a:ea typeface="Microsoft JhengHei"/>
                 <a:cs typeface="Microsoft JhengHei"/>
               </a:rPr>
-              <a:t>1/3</a:t>
-            </a:r>
-          </a:p>
-        </p:txBody>
-      </p:sp>
-      <p:sp>
-        <p:nvSpPr>
-          <p:cNvPr id="6" name="TextBox 5"/>
-          <p:cNvSpPr txBox="1"/>
-          <p:nvPr/>
-        </p:nvSpPr>
-        <p:spPr>
-          <a:xfrm>
-            <a:off x="777240" y="1234440"/>
-            <a:ext cx="10789920" cy="457200"/>
-          </a:xfrm>
-          <a:prstGeom prst="rect">
-            <a:avLst/>
-          </a:prstGeom>
-          <a:noFill/>
-        </p:spPr>
-        <p:txBody>
-          <a:bodyPr wrap="square" anchor="t">
-            <a:spAutoFit/>
-          </a:bodyPr>
-          <a:lstStyle/>
-          <a:p>
-            <a:pPr algn="l">
-              <a:lnSpc>
-                <a:spcPct val="105000"/>
-              </a:lnSpc>
-              <a:spcBef>
-                <a:spcPts val="0"/>
-              </a:spcBef>
-              <a:spcAft>
-                <a:spcPts val="200"/>
-              </a:spcAft>
-            </a:pPr>
-            <a:r>
-              <a:rPr sz="1300" b="0">
-                <a:solidFill>
-                  <a:srgbClr val="71717A"/>
-                </a:solidFill>
-                <a:latin typeface="Microsoft JhengHei"/>
-                <a:ea typeface="Microsoft JhengHei"/>
-                <a:cs typeface="Microsoft JhengHei"/>
-              </a:rPr>
-              <a:t>arxivLens — arXiv / HBR 論文聚合閱讀器，含 AI 摘要、關鍵字評分與多語翻譯</a:t>
-            </a:r>
-          </a:p>
-        </p:txBody>
-      </p:sp>
-      <p:sp>
-        <p:nvSpPr>
-          <p:cNvPr id="7" name="Rounded Rectangle 6"/>
-          <p:cNvSpPr/>
-          <p:nvPr/>
-        </p:nvSpPr>
-        <p:spPr>
-          <a:xfrm>
-            <a:off x="640080" y="2148840"/>
-            <a:ext cx="2331720" cy="1325880"/>
-          </a:xfrm>
-          <a:prstGeom prst="roundRect">
-            <a:avLst/>
-          </a:prstGeom>
-          <a:solidFill>
-            <a:srgbClr val="F4F4F5"/>
-          </a:solidFill>
-          <a:ln w="12700">
-            <a:solidFill>
-              <a:srgbClr val="E4E4E7"/>
-            </a:solidFill>
-          </a:ln>
-          <a:effectLst/>
-        </p:spPr>
-        <p:style>
-          <a:lnRef idx="1">
-            <a:schemeClr val="accent1"/>
-          </a:lnRef>
-          <a:fillRef idx="3">
-            <a:schemeClr val="accent1"/>
-          </a:fillRef>
-          <a:effectRef idx="2">
-            <a:schemeClr val="accent1"/>
-          </a:effectRef>
-          <a:fontRef idx="minor">
-            <a:schemeClr val="lt1"/>
-          </a:fontRef>
-        </p:style>
-        <p:txBody>
-          <a:bodyPr rtlCol="0" anchor="ctr" wrap="square" lIns="101600" rIns="101600" tIns="50800" bIns="50800"/>
-          <a:lstStyle/>
-          <a:p>
-            <a:pPr algn="ctr"/>
-            <a:r>
-              <a:rPr sz="1300" b="1">
-                <a:solidFill>
-                  <a:srgbClr val="18181B"/>
-                </a:solidFill>
-                <a:latin typeface="Microsoft JhengHei"/>
-                <a:ea typeface="Microsoft JhengHei"/>
-                <a:cs typeface="Microsoft JhengHei"/>
-              </a:rPr>
-              <a:t>使用者瀏覽器</a:t>
-            </a:r>
-          </a:p>
-          <a:p>
-            <a:pPr algn="ctr">
-              <a:lnSpc>
-                <a:spcPct val="100000"/>
-              </a:lnSpc>
-              <a:spcAft>
-                <a:spcPts val="0"/>
-              </a:spcAft>
-            </a:pPr>
-            <a:r>
-              <a:rPr sz="1050">
-                <a:solidFill>
-                  <a:srgbClr val="71717A"/>
-                </a:solidFill>
-                <a:latin typeface="Microsoft JhengHei"/>
-                <a:ea typeface="Microsoft JhengHei"/>
-                <a:cs typeface="Microsoft JhengHei"/>
-              </a:rPr>
-              <a:t>Browser</a:t>
-            </a:r>
-          </a:p>
-          <a:p>
-            <a:pPr algn="ctr">
-              <a:lnSpc>
-                <a:spcPct val="100000"/>
-              </a:lnSpc>
-              <a:spcAft>
-                <a:spcPts val="0"/>
-              </a:spcAft>
-            </a:pPr>
-            <a:r>
-              <a:rPr sz="1050">
-                <a:solidFill>
-                  <a:srgbClr val="71717A"/>
-                </a:solidFill>
-                <a:latin typeface="Microsoft JhengHei"/>
-                <a:ea typeface="Microsoft JhengHei"/>
-                <a:cs typeface="Microsoft JhengHei"/>
-              </a:rPr>
-              <a:t>桌機 / 行動裝置</a:t>
-            </a:r>
-          </a:p>
-        </p:txBody>
-      </p:sp>
-      <p:sp>
-        <p:nvSpPr>
-          <p:cNvPr id="8" name="Rounded Rectangle 7"/>
-          <p:cNvSpPr/>
-          <p:nvPr/>
-        </p:nvSpPr>
-        <p:spPr>
-          <a:xfrm>
-            <a:off x="3337560" y="2148840"/>
-            <a:ext cx="2331720" cy="1325880"/>
-          </a:xfrm>
-          <a:prstGeom prst="roundRect">
-            <a:avLst/>
-          </a:prstGeom>
-          <a:solidFill>
-            <a:srgbClr val="EFF6FF"/>
-          </a:solidFill>
-          <a:ln w="12700">
-            <a:solidFill>
-              <a:srgbClr val="93C5FD"/>
-            </a:solidFill>
-          </a:ln>
-          <a:effectLst/>
-        </p:spPr>
-        <p:style>
-          <a:lnRef idx="1">
-            <a:schemeClr val="accent1"/>
-          </a:lnRef>
-          <a:fillRef idx="3">
-            <a:schemeClr val="accent1"/>
-          </a:fillRef>
-          <a:effectRef idx="2">
-            <a:schemeClr val="accent1"/>
-          </a:effectRef>
-          <a:fontRef idx="minor">
-            <a:schemeClr val="lt1"/>
-          </a:fontRef>
-        </p:style>
-        <p:txBody>
-          <a:bodyPr rtlCol="0" anchor="ctr" wrap="square" lIns="101600" rIns="101600" tIns="50800" bIns="50800"/>
-          <a:lstStyle/>
-          <a:p>
-            <a:pPr algn="ctr"/>
-            <a:r>
-              <a:rPr sz="1300" b="1">
-                <a:solidFill>
-                  <a:srgbClr val="18181B"/>
-                </a:solidFill>
-                <a:latin typeface="Microsoft JhengHei"/>
-                <a:ea typeface="Microsoft JhengHei"/>
-                <a:cs typeface="Microsoft JhengHei"/>
-              </a:rPr>
-              <a:t>前端 Frontend</a:t>
-            </a:r>
-          </a:p>
-          <a:p>
-            <a:pPr algn="ctr">
-              <a:lnSpc>
-                <a:spcPct val="100000"/>
-              </a:lnSpc>
-              <a:spcAft>
-                <a:spcPts val="0"/>
-              </a:spcAft>
-            </a:pPr>
-            <a:r>
-              <a:rPr sz="1050">
-                <a:solidFill>
-                  <a:srgbClr val="71717A"/>
-                </a:solidFill>
-                <a:latin typeface="Microsoft JhengHei"/>
-                <a:ea typeface="Microsoft JhengHei"/>
-                <a:cs typeface="Microsoft JhengHei"/>
-              </a:rPr>
-              <a:t>Vercel</a:t>
-            </a:r>
-          </a:p>
-          <a:p>
-            <a:pPr algn="ctr">
-              <a:lnSpc>
-                <a:spcPct val="100000"/>
-              </a:lnSpc>
-              <a:spcAft>
-                <a:spcPts val="0"/>
-              </a:spcAft>
-            </a:pPr>
-            <a:r>
-              <a:rPr sz="1050">
-                <a:solidFill>
-                  <a:srgbClr val="71717A"/>
-                </a:solidFill>
-                <a:latin typeface="Microsoft JhengHei"/>
-                <a:ea typeface="Microsoft JhengHei"/>
-                <a:cs typeface="Microsoft JhengHei"/>
-              </a:rPr>
-              <a:t>Next.js 16 · React 19</a:t>
-            </a:r>
-          </a:p>
-          <a:p>
-            <a:pPr algn="ctr">
-              <a:lnSpc>
-                <a:spcPct val="100000"/>
-              </a:lnSpc>
-              <a:spcAft>
-                <a:spcPts val="0"/>
-              </a:spcAft>
-            </a:pPr>
-            <a:r>
-              <a:rPr sz="1050">
-                <a:solidFill>
-                  <a:srgbClr val="71717A"/>
-                </a:solidFill>
-                <a:latin typeface="Microsoft JhengHei"/>
-                <a:ea typeface="Microsoft JhengHei"/>
-                <a:cs typeface="Microsoft JhengHei"/>
-              </a:rPr>
-              <a:t>TypeScript · Tailwind 4</a:t>
-            </a:r>
-          </a:p>
-          <a:p>
-            <a:pPr algn="ctr">
-              <a:lnSpc>
-                <a:spcPct val="100000"/>
-              </a:lnSpc>
-              <a:spcAft>
-                <a:spcPts val="0"/>
-              </a:spcAft>
-            </a:pPr>
-            <a:r>
-              <a:rPr sz="1050">
-                <a:solidFill>
-                  <a:srgbClr val="71717A"/>
-                </a:solidFill>
-                <a:latin typeface="Microsoft JhengHei"/>
-                <a:ea typeface="Microsoft JhengHei"/>
-                <a:cs typeface="Microsoft JhengHei"/>
-              </a:rPr>
-              <a:t>Zustand</a:t>
-            </a:r>
-          </a:p>
-        </p:txBody>
-      </p:sp>
-      <p:sp>
-        <p:nvSpPr>
-          <p:cNvPr id="9" name="Rounded Rectangle 8"/>
-          <p:cNvSpPr/>
-          <p:nvPr/>
-        </p:nvSpPr>
-        <p:spPr>
-          <a:xfrm>
-            <a:off x="6035040" y="2148840"/>
-            <a:ext cx="2331720" cy="1325880"/>
-          </a:xfrm>
-          <a:prstGeom prst="roundRect">
-            <a:avLst/>
-          </a:prstGeom>
-          <a:solidFill>
-            <a:srgbClr val="ECFDF5"/>
-          </a:solidFill>
-          <a:ln w="12700">
-            <a:solidFill>
-              <a:srgbClr val="6EE7B7"/>
-            </a:solidFill>
-          </a:ln>
-          <a:effectLst/>
-        </p:spPr>
-        <p:style>
-          <a:lnRef idx="1">
-            <a:schemeClr val="accent1"/>
-          </a:lnRef>
-          <a:fillRef idx="3">
-            <a:schemeClr val="accent1"/>
-          </a:fillRef>
-          <a:effectRef idx="2">
-            <a:schemeClr val="accent1"/>
-          </a:effectRef>
-          <a:fontRef idx="minor">
-            <a:schemeClr val="lt1"/>
-          </a:fontRef>
-        </p:style>
-        <p:txBody>
-          <a:bodyPr rtlCol="0" anchor="ctr" wrap="square" lIns="101600" rIns="101600" tIns="50800" bIns="50800"/>
-          <a:lstStyle/>
-          <a:p>
-            <a:pPr algn="ctr"/>
-            <a:r>
-              <a:rPr sz="1300" b="1">
-                <a:solidFill>
-                  <a:srgbClr val="18181B"/>
-                </a:solidFill>
-                <a:latin typeface="Microsoft JhengHei"/>
-                <a:ea typeface="Microsoft JhengHei"/>
-                <a:cs typeface="Microsoft JhengHei"/>
-              </a:rPr>
-              <a:t>後端 Backend</a:t>
-            </a:r>
-          </a:p>
-          <a:p>
-            <a:pPr algn="ctr">
-              <a:lnSpc>
-                <a:spcPct val="100000"/>
-              </a:lnSpc>
-              <a:spcAft>
-                <a:spcPts val="0"/>
-              </a:spcAft>
-            </a:pPr>
-            <a:r>
-              <a:rPr sz="1050">
-                <a:solidFill>
-                  <a:srgbClr val="71717A"/>
-                </a:solidFill>
-                <a:latin typeface="Microsoft JhengHei"/>
-                <a:ea typeface="Microsoft JhengHei"/>
-                <a:cs typeface="Microsoft JhengHei"/>
-              </a:rPr>
-              <a:t>Render (Docker)</a:t>
-            </a:r>
-          </a:p>
-          <a:p>
-            <a:pPr algn="ctr">
-              <a:lnSpc>
-                <a:spcPct val="100000"/>
-              </a:lnSpc>
-              <a:spcAft>
-                <a:spcPts val="0"/>
-              </a:spcAft>
-            </a:pPr>
-            <a:r>
-              <a:rPr sz="1050">
-                <a:solidFill>
-                  <a:srgbClr val="71717A"/>
-                </a:solidFill>
-                <a:latin typeface="Microsoft JhengHei"/>
-                <a:ea typeface="Microsoft JhengHei"/>
-                <a:cs typeface="Microsoft JhengHei"/>
-              </a:rPr>
-              <a:t>Spring Boot 4 · Java 25</a:t>
-            </a:r>
-          </a:p>
-          <a:p>
-            <a:pPr algn="ctr">
-              <a:lnSpc>
-                <a:spcPct val="100000"/>
-              </a:lnSpc>
-              <a:spcAft>
-                <a:spcPts val="0"/>
-              </a:spcAft>
-            </a:pPr>
-            <a:r>
-              <a:rPr sz="1050">
-                <a:solidFill>
-                  <a:srgbClr val="71717A"/>
-                </a:solidFill>
-                <a:latin typeface="Microsoft JhengHei"/>
-                <a:ea typeface="Microsoft JhengHei"/>
-                <a:cs typeface="Microsoft JhengHei"/>
-              </a:rPr>
-              <a:t>Spring Security · JWT</a:t>
-            </a:r>
-          </a:p>
-        </p:txBody>
-      </p:sp>
-      <p:sp>
-        <p:nvSpPr>
-          <p:cNvPr id="10" name="Rounded Rectangle 9"/>
-          <p:cNvSpPr/>
-          <p:nvPr/>
-        </p:nvSpPr>
-        <p:spPr>
-          <a:xfrm>
-            <a:off x="8732520" y="2148840"/>
-            <a:ext cx="2331720" cy="1325880"/>
-          </a:xfrm>
-          <a:prstGeom prst="roundRect">
-            <a:avLst/>
-          </a:prstGeom>
-          <a:solidFill>
-            <a:srgbClr val="FEF3C7"/>
-          </a:solidFill>
-          <a:ln w="12700">
-            <a:solidFill>
-              <a:srgbClr val="FCD34D"/>
-            </a:solidFill>
-          </a:ln>
-          <a:effectLst/>
-        </p:spPr>
-        <p:style>
-          <a:lnRef idx="1">
-            <a:schemeClr val="accent1"/>
-          </a:lnRef>
-          <a:fillRef idx="3">
-            <a:schemeClr val="accent1"/>
-          </a:fillRef>
-          <a:effectRef idx="2">
-            <a:schemeClr val="accent1"/>
-          </a:effectRef>
-          <a:fontRef idx="minor">
-            <a:schemeClr val="lt1"/>
-          </a:fontRef>
-        </p:style>
-        <p:txBody>
-          <a:bodyPr rtlCol="0" anchor="ctr" wrap="square" lIns="101600" rIns="101600" tIns="50800" bIns="50800"/>
-          <a:lstStyle/>
-          <a:p>
-            <a:pPr algn="ctr"/>
-            <a:r>
-              <a:rPr sz="1300" b="1">
-                <a:solidFill>
-                  <a:srgbClr val="18181B"/>
-                </a:solidFill>
-                <a:latin typeface="Microsoft JhengHei"/>
-                <a:ea typeface="Microsoft JhengHei"/>
-                <a:cs typeface="Microsoft JhengHei"/>
-              </a:rPr>
-              <a:t>資料庫 Database</a:t>
-            </a:r>
-          </a:p>
-          <a:p>
-            <a:pPr algn="ctr">
-              <a:lnSpc>
-                <a:spcPct val="100000"/>
-              </a:lnSpc>
-              <a:spcAft>
-                <a:spcPts val="0"/>
-              </a:spcAft>
-            </a:pPr>
-            <a:r>
-              <a:rPr sz="1050">
-                <a:solidFill>
-                  <a:srgbClr val="71717A"/>
-                </a:solidFill>
-                <a:latin typeface="Microsoft JhengHei"/>
-                <a:ea typeface="Microsoft JhengHei"/>
-                <a:cs typeface="Microsoft JhengHei"/>
-              </a:rPr>
-              <a:t>TiDB Cloud Serverless</a:t>
-            </a:r>
-          </a:p>
-          <a:p>
-            <a:pPr algn="ctr">
-              <a:lnSpc>
-                <a:spcPct val="100000"/>
-              </a:lnSpc>
-              <a:spcAft>
-                <a:spcPts val="0"/>
-              </a:spcAft>
-            </a:pPr>
-            <a:r>
-              <a:rPr sz="1050">
-                <a:solidFill>
-                  <a:srgbClr val="71717A"/>
-                </a:solidFill>
-                <a:latin typeface="Microsoft JhengHei"/>
-                <a:ea typeface="Microsoft JhengHei"/>
-                <a:cs typeface="Microsoft JhengHei"/>
-              </a:rPr>
-              <a:t>(MySQL 相容)</a:t>
-            </a:r>
-          </a:p>
-          <a:p>
-            <a:pPr algn="ctr">
-              <a:lnSpc>
-                <a:spcPct val="100000"/>
-              </a:lnSpc>
-              <a:spcAft>
-                <a:spcPts val="0"/>
-              </a:spcAft>
-            </a:pPr>
-            <a:r>
-              <a:rPr sz="1050">
-                <a:solidFill>
-                  <a:srgbClr val="71717A"/>
-                </a:solidFill>
-                <a:latin typeface="Microsoft JhengHei"/>
-                <a:ea typeface="Microsoft JhengHei"/>
-                <a:cs typeface="Microsoft JhengHei"/>
-              </a:rPr>
-              <a:t>本地開發用 MySQL 8</a:t>
-            </a:r>
-          </a:p>
-        </p:txBody>
-      </p:sp>
-      <p:sp>
-        <p:nvSpPr>
-          <p:cNvPr id="11" name="TextBox 10"/>
-          <p:cNvSpPr txBox="1"/>
-          <p:nvPr/>
-        </p:nvSpPr>
-        <p:spPr>
-          <a:xfrm>
-            <a:off x="3017520" y="2148840"/>
-            <a:ext cx="320040" cy="1325880"/>
-          </a:xfrm>
-          <a:prstGeom prst="rect">
-            <a:avLst/>
-          </a:prstGeom>
-          <a:noFill/>
-        </p:spPr>
-        <p:txBody>
-          <a:bodyPr wrap="square" anchor="ctr">
-            <a:spAutoFit/>
-          </a:bodyPr>
-          <a:lstStyle/>
-          <a:p>
-            <a:pPr algn="ctr">
-              <a:lnSpc>
-                <a:spcPct val="105000"/>
-              </a:lnSpc>
-              <a:spcBef>
-                <a:spcPts val="0"/>
-              </a:spcBef>
-              <a:spcAft>
-                <a:spcPts val="200"/>
-              </a:spcAft>
-            </a:pPr>
-            <a:r>
-              <a:rPr sz="2000" b="1">
-                <a:solidFill>
-                  <a:srgbClr val="2563EB"/>
-                </a:solidFill>
-                <a:latin typeface="Microsoft JhengHei"/>
-                <a:ea typeface="Microsoft JhengHei"/>
-                <a:cs typeface="Microsoft JhengHei"/>
-              </a:rPr>
-              <a:t>→</a:t>
-            </a:r>
-          </a:p>
-        </p:txBody>
-      </p:sp>
-      <p:sp>
-        <p:nvSpPr>
-          <p:cNvPr id="12" name="TextBox 11"/>
-          <p:cNvSpPr txBox="1"/>
-          <p:nvPr/>
-        </p:nvSpPr>
-        <p:spPr>
-          <a:xfrm>
-            <a:off x="5715000" y="2148840"/>
-            <a:ext cx="320040" cy="1325880"/>
-          </a:xfrm>
-          <a:prstGeom prst="rect">
-            <a:avLst/>
-          </a:prstGeom>
-          <a:noFill/>
-        </p:spPr>
-        <p:txBody>
-          <a:bodyPr wrap="square" anchor="ctr">
-            <a:spAutoFit/>
-          </a:bodyPr>
-          <a:lstStyle/>
-          <a:p>
-            <a:pPr algn="ctr">
-              <a:lnSpc>
-                <a:spcPct val="105000"/>
-              </a:lnSpc>
-              <a:spcBef>
-                <a:spcPts val="0"/>
-              </a:spcBef>
-              <a:spcAft>
-                <a:spcPts val="200"/>
-              </a:spcAft>
-            </a:pPr>
-            <a:r>
-              <a:rPr sz="2000" b="1">
-                <a:solidFill>
-                  <a:srgbClr val="2563EB"/>
-                </a:solidFill>
-                <a:latin typeface="Microsoft JhengHei"/>
-                <a:ea typeface="Microsoft JhengHei"/>
-                <a:cs typeface="Microsoft JhengHei"/>
-              </a:rPr>
-              <a:t>→</a:t>
-            </a:r>
-          </a:p>
-        </p:txBody>
-      </p:sp>
-      <p:sp>
-        <p:nvSpPr>
-          <p:cNvPr id="13" name="TextBox 12"/>
-          <p:cNvSpPr txBox="1"/>
-          <p:nvPr/>
-        </p:nvSpPr>
-        <p:spPr>
-          <a:xfrm>
-            <a:off x="8412480" y="2148840"/>
-            <a:ext cx="320040" cy="1325880"/>
-          </a:xfrm>
-          <a:prstGeom prst="rect">
-            <a:avLst/>
-          </a:prstGeom>
-          <a:noFill/>
-        </p:spPr>
-        <p:txBody>
-          <a:bodyPr wrap="square" anchor="ctr">
-            <a:spAutoFit/>
-          </a:bodyPr>
-          <a:lstStyle/>
-          <a:p>
-            <a:pPr algn="ctr">
-              <a:lnSpc>
-                <a:spcPct val="105000"/>
-              </a:lnSpc>
-              <a:spcBef>
-                <a:spcPts val="0"/>
-              </a:spcBef>
-              <a:spcAft>
-                <a:spcPts val="200"/>
-              </a:spcAft>
-            </a:pPr>
-            <a:r>
-              <a:rPr sz="2000" b="1">
-                <a:solidFill>
-                  <a:srgbClr val="2563EB"/>
-                </a:solidFill>
-                <a:latin typeface="Microsoft JhengHei"/>
-                <a:ea typeface="Microsoft JhengHei"/>
-                <a:cs typeface="Microsoft JhengHei"/>
-              </a:rPr>
-              <a:t>→</a:t>
-            </a:r>
-          </a:p>
-        </p:txBody>
-      </p:sp>
-      <p:sp>
-        <p:nvSpPr>
-          <p:cNvPr id="14" name="TextBox 13"/>
-          <p:cNvSpPr txBox="1"/>
-          <p:nvPr/>
-        </p:nvSpPr>
-        <p:spPr>
-          <a:xfrm>
-            <a:off x="3337560" y="3493008"/>
-            <a:ext cx="5394960" cy="274320"/>
-          </a:xfrm>
-          <a:prstGeom prst="rect">
-            <a:avLst/>
-          </a:prstGeom>
-          <a:noFill/>
-        </p:spPr>
-        <p:txBody>
-          <a:bodyPr wrap="square" anchor="t">
-            <a:spAutoFit/>
-          </a:bodyPr>
-          <a:lstStyle/>
-          <a:p>
-            <a:pPr algn="ctr">
-              <a:lnSpc>
-                <a:spcPct val="105000"/>
-              </a:lnSpc>
-              <a:spcBef>
-                <a:spcPts val="0"/>
-              </a:spcBef>
-              <a:spcAft>
-                <a:spcPts val="200"/>
-              </a:spcAft>
-            </a:pPr>
-            <a:r>
-              <a:rPr sz="900" b="0">
-                <a:solidFill>
-                  <a:srgbClr val="71717A"/>
-                </a:solidFill>
-                <a:latin typeface="Microsoft JhengHei"/>
-                <a:ea typeface="Microsoft JhengHei"/>
-                <a:cs typeface="Microsoft JhengHei"/>
-              </a:rPr>
-              <a:t>HTTPS · REST / JSON · JWT</a:t>
-            </a:r>
-          </a:p>
-        </p:txBody>
-      </p:sp>
-      <p:sp>
-        <p:nvSpPr>
-          <p:cNvPr id="15" name="TextBox 14"/>
-          <p:cNvSpPr txBox="1"/>
-          <p:nvPr/>
-        </p:nvSpPr>
-        <p:spPr>
-          <a:xfrm>
-            <a:off x="7018020" y="3429000"/>
-            <a:ext cx="365760" cy="502920"/>
-          </a:xfrm>
-          <a:prstGeom prst="rect">
-            <a:avLst/>
-          </a:prstGeom>
-          <a:noFill/>
-        </p:spPr>
-        <p:txBody>
-          <a:bodyPr wrap="square" anchor="ctr">
-            <a:spAutoFit/>
-          </a:bodyPr>
-          <a:lstStyle/>
-          <a:p>
-            <a:pPr algn="ctr">
-              <a:lnSpc>
-                <a:spcPct val="105000"/>
-              </a:lnSpc>
-              <a:spcBef>
-                <a:spcPts val="0"/>
-              </a:spcBef>
-              <a:spcAft>
-                <a:spcPts val="200"/>
-              </a:spcAft>
-            </a:pPr>
-            <a:r>
-              <a:rPr sz="1800" b="1">
-                <a:solidFill>
-                  <a:srgbClr val="2563EB"/>
-                </a:solidFill>
-                <a:latin typeface="Microsoft JhengHei"/>
-                <a:ea typeface="Microsoft JhengHei"/>
-                <a:cs typeface="Microsoft JhengHei"/>
-              </a:rPr>
-              <a:t>↓</a:t>
-            </a:r>
-          </a:p>
-        </p:txBody>
-      </p:sp>
-      <p:sp>
-        <p:nvSpPr>
-          <p:cNvPr id="16" name="Rounded Rectangle 15"/>
-          <p:cNvSpPr/>
-          <p:nvPr/>
-        </p:nvSpPr>
-        <p:spPr>
-          <a:xfrm>
-            <a:off x="640080" y="4069080"/>
-            <a:ext cx="10424160" cy="1234440"/>
-          </a:xfrm>
-          <a:prstGeom prst="roundRect">
-            <a:avLst/>
-          </a:prstGeom>
-          <a:solidFill>
-            <a:srgbClr val="FFFFFF"/>
-          </a:solidFill>
-          <a:ln w="12700">
-            <a:solidFill>
-              <a:srgbClr val="E4E4E7"/>
-            </a:solidFill>
-          </a:ln>
-          <a:effectLst/>
-        </p:spPr>
-        <p:style>
-          <a:lnRef idx="1">
-            <a:schemeClr val="accent1"/>
-          </a:lnRef>
-          <a:fillRef idx="3">
-            <a:schemeClr val="accent1"/>
-          </a:fillRef>
-          <a:effectRef idx="2">
-            <a:schemeClr val="accent1"/>
-          </a:effectRef>
-          <a:fontRef idx="minor">
-            <a:schemeClr val="lt1"/>
-          </a:fontRef>
-        </p:style>
-        <p:txBody>
-          <a:bodyPr rtlCol="0" anchor="ctr" wrap="square" lIns="101600" rIns="101600" tIns="50800" bIns="50800"/>
-          <a:lstStyle/>
-          <a:p>
-            <a:pPr algn="ctr"/>
-            <a:r>
-              <a:rPr sz="1300" b="1">
-                <a:solidFill>
-                  <a:srgbClr val="18181B"/>
-                </a:solidFill>
-                <a:latin typeface="Microsoft JhengHei"/>
-                <a:ea typeface="Microsoft JhengHei"/>
-                <a:cs typeface="Microsoft JhengHei"/>
-              </a:rPr>
-              <a:t>外部整合 External integrations</a:t>
-            </a:r>
-          </a:p>
-        </p:txBody>
-      </p:sp>
-      <p:sp>
-        <p:nvSpPr>
-          <p:cNvPr id="17" name="Rounded Rectangle 16"/>
-          <p:cNvSpPr/>
-          <p:nvPr/>
-        </p:nvSpPr>
-        <p:spPr>
-          <a:xfrm>
-            <a:off x="868680" y="4480560"/>
-            <a:ext cx="1938528" cy="713232"/>
-          </a:xfrm>
-          <a:prstGeom prst="roundRect">
-            <a:avLst/>
-          </a:prstGeom>
-          <a:solidFill>
-            <a:srgbClr val="F4F4F5"/>
-          </a:solidFill>
-          <a:ln w="12700">
-            <a:solidFill>
-              <a:srgbClr val="E4E4E7"/>
-            </a:solidFill>
-          </a:ln>
-          <a:effectLst/>
-        </p:spPr>
-        <p:style>
-          <a:lnRef idx="1">
-            <a:schemeClr val="accent1"/>
-          </a:lnRef>
-          <a:fillRef idx="3">
-            <a:schemeClr val="accent1"/>
-          </a:fillRef>
-          <a:effectRef idx="2">
-            <a:schemeClr val="accent1"/>
-          </a:effectRef>
-          <a:fontRef idx="minor">
-            <a:schemeClr val="lt1"/>
-          </a:fontRef>
-        </p:style>
-        <p:txBody>
-          <a:bodyPr rtlCol="0" anchor="ctr" wrap="square" lIns="101600" rIns="101600" tIns="50800" bIns="50800"/>
-          <a:lstStyle/>
-          <a:p>
-            <a:pPr algn="ctr"/>
-            <a:r>
-              <a:rPr sz="1050" b="1">
-                <a:solidFill>
-                  <a:srgbClr val="18181B"/>
-                </a:solidFill>
-                <a:latin typeface="Microsoft JhengHei"/>
-                <a:ea typeface="Microsoft JhengHei"/>
-                <a:cs typeface="Microsoft JhengHei"/>
-              </a:rPr>
-              <a:t>arXiv Atom API</a:t>
-            </a:r>
-          </a:p>
-          <a:p>
-            <a:pPr algn="ctr">
-              <a:lnSpc>
-                <a:spcPct val="100000"/>
-              </a:lnSpc>
-              <a:spcAft>
-                <a:spcPts val="0"/>
-              </a:spcAft>
-            </a:pPr>
-            <a:r>
-              <a:rPr sz="900">
-                <a:solidFill>
-                  <a:srgbClr val="71717A"/>
-                </a:solidFill>
-                <a:latin typeface="Microsoft JhengHei"/>
-                <a:ea typeface="Microsoft JhengHei"/>
-                <a:cs typeface="Microsoft JhengHei"/>
-              </a:rPr>
-              <a:t>論文同步</a:t>
-            </a:r>
-          </a:p>
-        </p:txBody>
-      </p:sp>
-      <p:sp>
-        <p:nvSpPr>
-          <p:cNvPr id="18" name="Rounded Rectangle 17"/>
-          <p:cNvSpPr/>
-          <p:nvPr/>
-        </p:nvSpPr>
-        <p:spPr>
-          <a:xfrm>
-            <a:off x="2916936" y="4480560"/>
-            <a:ext cx="1938528" cy="713232"/>
-          </a:xfrm>
-          <a:prstGeom prst="roundRect">
-            <a:avLst/>
-          </a:prstGeom>
-          <a:solidFill>
-            <a:srgbClr val="F4F4F5"/>
-          </a:solidFill>
-          <a:ln w="12700">
-            <a:solidFill>
-              <a:srgbClr val="E4E4E7"/>
-            </a:solidFill>
-          </a:ln>
-          <a:effectLst/>
-        </p:spPr>
-        <p:style>
-          <a:lnRef idx="1">
-            <a:schemeClr val="accent1"/>
-          </a:lnRef>
-          <a:fillRef idx="3">
-            <a:schemeClr val="accent1"/>
-          </a:fillRef>
-          <a:effectRef idx="2">
-            <a:schemeClr val="accent1"/>
-          </a:effectRef>
-          <a:fontRef idx="minor">
-            <a:schemeClr val="lt1"/>
-          </a:fontRef>
-        </p:style>
-        <p:txBody>
-          <a:bodyPr rtlCol="0" anchor="ctr" wrap="square" lIns="101600" rIns="101600" tIns="50800" bIns="50800"/>
-          <a:lstStyle/>
-          <a:p>
-            <a:pPr algn="ctr"/>
-            <a:r>
-              <a:rPr sz="1050" b="1">
-                <a:solidFill>
-                  <a:srgbClr val="18181B"/>
-                </a:solidFill>
-                <a:latin typeface="Microsoft JhengHei"/>
-                <a:ea typeface="Microsoft JhengHei"/>
-                <a:cs typeface="Microsoft JhengHei"/>
-              </a:rPr>
-              <a:t>HBR RSS</a:t>
-            </a:r>
-          </a:p>
-          <a:p>
-            <a:pPr algn="ctr">
-              <a:lnSpc>
-                <a:spcPct val="100000"/>
-              </a:lnSpc>
-              <a:spcAft>
-                <a:spcPts val="0"/>
-              </a:spcAft>
-            </a:pPr>
-            <a:r>
-              <a:rPr sz="900">
-                <a:solidFill>
-                  <a:srgbClr val="71717A"/>
-                </a:solidFill>
-                <a:latin typeface="Microsoft JhengHei"/>
-                <a:ea typeface="Microsoft JhengHei"/>
-                <a:cs typeface="Microsoft JhengHei"/>
-              </a:rPr>
-              <a:t>文章來源</a:t>
-            </a:r>
-          </a:p>
-        </p:txBody>
-      </p:sp>
-      <p:sp>
-        <p:nvSpPr>
-          <p:cNvPr id="19" name="Rounded Rectangle 18"/>
-          <p:cNvSpPr/>
-          <p:nvPr/>
-        </p:nvSpPr>
-        <p:spPr>
-          <a:xfrm>
-            <a:off x="4965192" y="4480560"/>
-            <a:ext cx="1938528" cy="713232"/>
-          </a:xfrm>
-          <a:prstGeom prst="roundRect">
-            <a:avLst/>
-          </a:prstGeom>
-          <a:solidFill>
-            <a:srgbClr val="F4F4F5"/>
-          </a:solidFill>
-          <a:ln w="12700">
-            <a:solidFill>
-              <a:srgbClr val="E4E4E7"/>
-            </a:solidFill>
-          </a:ln>
-          <a:effectLst/>
-        </p:spPr>
-        <p:style>
-          <a:lnRef idx="1">
-            <a:schemeClr val="accent1"/>
-          </a:lnRef>
-          <a:fillRef idx="3">
-            <a:schemeClr val="accent1"/>
-          </a:fillRef>
-          <a:effectRef idx="2">
-            <a:schemeClr val="accent1"/>
-          </a:effectRef>
-          <a:fontRef idx="minor">
-            <a:schemeClr val="lt1"/>
-          </a:fontRef>
-        </p:style>
-        <p:txBody>
-          <a:bodyPr rtlCol="0" anchor="ctr" wrap="square" lIns="101600" rIns="101600" tIns="50800" bIns="50800"/>
-          <a:lstStyle/>
-          <a:p>
-            <a:pPr algn="ctr"/>
-            <a:r>
-              <a:rPr sz="1050" b="1">
-                <a:solidFill>
-                  <a:srgbClr val="18181B"/>
-                </a:solidFill>
-                <a:latin typeface="Microsoft JhengHei"/>
-                <a:ea typeface="Microsoft JhengHei"/>
-                <a:cs typeface="Microsoft JhengHei"/>
-              </a:rPr>
-              <a:t>Google Gemini 2.5 Flash</a:t>
-            </a:r>
-          </a:p>
-          <a:p>
-            <a:pPr algn="ctr">
-              <a:lnSpc>
-                <a:spcPct val="100000"/>
-              </a:lnSpc>
-              <a:spcAft>
-                <a:spcPts val="0"/>
-              </a:spcAft>
-            </a:pPr>
-            <a:r>
-              <a:rPr sz="900">
-                <a:solidFill>
-                  <a:srgbClr val="71717A"/>
-                </a:solidFill>
-                <a:latin typeface="Microsoft JhengHei"/>
-                <a:ea typeface="Microsoft JhengHei"/>
-                <a:cs typeface="Microsoft JhengHei"/>
-              </a:rPr>
-              <a:t>摘要 / 翻譯</a:t>
-            </a:r>
-          </a:p>
-        </p:txBody>
-      </p:sp>
-      <p:sp>
-        <p:nvSpPr>
-          <p:cNvPr id="20" name="Rounded Rectangle 19"/>
-          <p:cNvSpPr/>
-          <p:nvPr/>
-        </p:nvSpPr>
-        <p:spPr>
-          <a:xfrm>
-            <a:off x="7013448" y="4480560"/>
-            <a:ext cx="1938528" cy="713232"/>
-          </a:xfrm>
-          <a:prstGeom prst="roundRect">
-            <a:avLst/>
-          </a:prstGeom>
-          <a:solidFill>
-            <a:srgbClr val="F4F4F5"/>
-          </a:solidFill>
-          <a:ln w="12700">
-            <a:solidFill>
-              <a:srgbClr val="E4E4E7"/>
-            </a:solidFill>
-          </a:ln>
-          <a:effectLst/>
-        </p:spPr>
-        <p:style>
-          <a:lnRef idx="1">
-            <a:schemeClr val="accent1"/>
-          </a:lnRef>
-          <a:fillRef idx="3">
-            <a:schemeClr val="accent1"/>
-          </a:fillRef>
-          <a:effectRef idx="2">
-            <a:schemeClr val="accent1"/>
-          </a:effectRef>
-          <a:fontRef idx="minor">
-            <a:schemeClr val="lt1"/>
-          </a:fontRef>
-        </p:style>
-        <p:txBody>
-          <a:bodyPr rtlCol="0" anchor="ctr" wrap="square" lIns="101600" rIns="101600" tIns="50800" bIns="50800"/>
-          <a:lstStyle/>
-          <a:p>
-            <a:pPr algn="ctr"/>
-            <a:r>
-              <a:rPr sz="1050" b="1">
-                <a:solidFill>
-                  <a:srgbClr val="18181B"/>
-                </a:solidFill>
-                <a:latin typeface="Microsoft JhengHei"/>
-                <a:ea typeface="Microsoft JhengHei"/>
-                <a:cs typeface="Microsoft JhengHei"/>
-              </a:rPr>
-              <a:t>Resend</a:t>
-            </a:r>
-          </a:p>
-          <a:p>
-            <a:pPr algn="ctr">
-              <a:lnSpc>
-                <a:spcPct val="100000"/>
-              </a:lnSpc>
-              <a:spcAft>
-                <a:spcPts val="0"/>
-              </a:spcAft>
-            </a:pPr>
-            <a:r>
-              <a:rPr sz="900">
-                <a:solidFill>
-                  <a:srgbClr val="71717A"/>
-                </a:solidFill>
-                <a:latin typeface="Microsoft JhengHei"/>
-                <a:ea typeface="Microsoft JhengHei"/>
-                <a:cs typeface="Microsoft JhengHei"/>
-              </a:rPr>
-              <a:t>Email 通知</a:t>
-            </a:r>
-          </a:p>
-        </p:txBody>
-      </p:sp>
-      <p:sp>
-        <p:nvSpPr>
-          <p:cNvPr id="21" name="Rounded Rectangle 20"/>
-          <p:cNvSpPr/>
-          <p:nvPr/>
-        </p:nvSpPr>
-        <p:spPr>
-          <a:xfrm>
-            <a:off x="9061704" y="4480560"/>
-            <a:ext cx="1938528" cy="713232"/>
-          </a:xfrm>
-          <a:prstGeom prst="roundRect">
-            <a:avLst/>
-          </a:prstGeom>
-          <a:solidFill>
-            <a:srgbClr val="F4F4F5"/>
-          </a:solidFill>
-          <a:ln w="12700">
-            <a:solidFill>
-              <a:srgbClr val="E4E4E7"/>
-            </a:solidFill>
-          </a:ln>
-          <a:effectLst/>
-        </p:spPr>
-        <p:style>
-          <a:lnRef idx="1">
-            <a:schemeClr val="accent1"/>
-          </a:lnRef>
-          <a:fillRef idx="3">
-            <a:schemeClr val="accent1"/>
-          </a:fillRef>
-          <a:effectRef idx="2">
-            <a:schemeClr val="accent1"/>
-          </a:effectRef>
-          <a:fontRef idx="minor">
-            <a:schemeClr val="lt1"/>
-          </a:fontRef>
-        </p:style>
-        <p:txBody>
-          <a:bodyPr rtlCol="0" anchor="ctr" wrap="square" lIns="101600" rIns="101600" tIns="50800" bIns="50800"/>
-          <a:lstStyle/>
-          <a:p>
-            <a:pPr algn="ctr"/>
-            <a:r>
-              <a:rPr sz="1050" b="1">
-                <a:solidFill>
-                  <a:srgbClr val="18181B"/>
-                </a:solidFill>
-                <a:latin typeface="Microsoft JhengHei"/>
-                <a:ea typeface="Microsoft JhengHei"/>
-                <a:cs typeface="Microsoft JhengHei"/>
-              </a:rPr>
-              <a:t>GitHub Actions</a:t>
-            </a:r>
-          </a:p>
-          <a:p>
-            <a:pPr algn="ctr">
-              <a:lnSpc>
-                <a:spcPct val="100000"/>
-              </a:lnSpc>
-              <a:spcAft>
-                <a:spcPts val="0"/>
-              </a:spcAft>
-            </a:pPr>
-            <a:r>
-              <a:rPr sz="900">
-                <a:solidFill>
-                  <a:srgbClr val="71717A"/>
-                </a:solidFill>
-                <a:latin typeface="Microsoft JhengHei"/>
-                <a:ea typeface="Microsoft JhengHei"/>
-                <a:cs typeface="Microsoft JhengHei"/>
-              </a:rPr>
-              <a:t>每 6 小時 cron</a:t>
-            </a:r>
-          </a:p>
-        </p:txBody>
-      </p:sp>
-      <p:sp>
-        <p:nvSpPr>
-          <p:cNvPr id="22" name="TextBox 21"/>
-          <p:cNvSpPr txBox="1"/>
-          <p:nvPr/>
-        </p:nvSpPr>
-        <p:spPr>
-          <a:xfrm>
-            <a:off x="640080" y="6355080"/>
-            <a:ext cx="10789920" cy="365760"/>
-          </a:xfrm>
-          <a:prstGeom prst="rect">
-            <a:avLst/>
-          </a:prstGeom>
-          <a:noFill/>
-        </p:spPr>
-        <p:txBody>
-          <a:bodyPr wrap="square" anchor="t">
-            <a:spAutoFit/>
-          </a:bodyPr>
-          <a:lstStyle/>
-          <a:p>
-            <a:pPr algn="l">
-              <a:lnSpc>
-                <a:spcPct val="105000"/>
-              </a:lnSpc>
-              <a:spcBef>
-                <a:spcPts val="0"/>
-              </a:spcBef>
-              <a:spcAft>
-                <a:spcPts val="200"/>
-              </a:spcAft>
-            </a:pPr>
-            <a:r>
-              <a:rPr sz="1050" b="0">
-                <a:solidFill>
-                  <a:srgbClr val="71717A"/>
-                </a:solidFill>
-                <a:latin typeface="Microsoft JhengHei"/>
-                <a:ea typeface="Microsoft JhengHei"/>
-                <a:cs typeface="Microsoft JhengHei"/>
-              </a:rPr>
-              <a:t>部署：Vercel（前端）· Render（後端）· TiDB Cloud（資料庫）— 全部免費方案</a:t>
+              <a:t>2026.06</a:t>
             </a:r>
           </a:p>
         </p:txBody>
@@ -4687,7 +3617,7 @@
                 <a:ea typeface="Microsoft JhengHei"/>
                 <a:cs typeface="Microsoft JhengHei"/>
               </a:rPr>
-              <a:t>系統特色  </a:t>
+              <a:t>系統架構  </a:t>
             </a:r>
             <a:r>
               <a:rPr sz="1500" b="0">
@@ -4698,7 +3628,7 @@
                 <a:ea typeface="Microsoft JhengHei"/>
                 <a:cs typeface="Microsoft JhengHei"/>
               </a:rPr>
-              <a:t>Key Features</a:t>
+              <a:t>System Architecture</a:t>
             </a:r>
           </a:p>
         </p:txBody>
@@ -4745,7 +3675,7 @@
                 <a:ea typeface="Microsoft JhengHei"/>
                 <a:cs typeface="Microsoft JhengHei"/>
               </a:rPr>
-              <a:t>2/3</a:t>
+              <a:t>1/3</a:t>
             </a:r>
           </a:p>
         </p:txBody>
@@ -4758,8 +3688,8 @@
         </p:nvSpPr>
         <p:spPr>
           <a:xfrm>
-            <a:off x="640080" y="1417320"/>
-            <a:ext cx="5394960" cy="365760"/>
+            <a:off x="777240" y="1234440"/>
+            <a:ext cx="10789920" cy="457200"/>
           </a:xfrm>
           <a:prstGeom prst="rect">
             <a:avLst/>
@@ -4784,6 +3714,1473 @@
               </a:spcAft>
             </a:pPr>
             <a:r>
+              <a:rPr sz="1300" b="0">
+                <a:solidFill>
+                  <a:srgbClr val="71717A"/>
+                </a:solidFill>
+                <a:latin typeface="Microsoft JhengHei"/>
+                <a:ea typeface="Microsoft JhengHei"/>
+                <a:cs typeface="Microsoft JhengHei"/>
+              </a:rPr>
+              <a:t>arxivLens — arXiv / HBR 論文聚合閱讀器，含 AI 摘要、關鍵字評分與多語翻譯</a:t>
+            </a:r>
+          </a:p>
+        </p:txBody>
+      </p:sp>
+      <p:sp>
+        <p:nvSpPr>
+          <p:cNvPr id="7" name="Rounded Rectangle 6"/>
+          <p:cNvSpPr/>
+          <p:nvPr/>
+        </p:nvSpPr>
+        <p:spPr>
+          <a:xfrm>
+            <a:off x="640080" y="2148840"/>
+            <a:ext cx="2331720" cy="1325880"/>
+          </a:xfrm>
+          <a:prstGeom prst="roundRect">
+            <a:avLst/>
+          </a:prstGeom>
+          <a:solidFill>
+            <a:srgbClr val="F4F4F5"/>
+          </a:solidFill>
+          <a:ln w="12700">
+            <a:solidFill>
+              <a:srgbClr val="E4E4E7"/>
+            </a:solidFill>
+          </a:ln>
+          <a:effectLst/>
+        </p:spPr>
+        <p:style>
+          <a:lnRef idx="1">
+            <a:schemeClr val="accent1"/>
+          </a:lnRef>
+          <a:fillRef idx="3">
+            <a:schemeClr val="accent1"/>
+          </a:fillRef>
+          <a:effectRef idx="2">
+            <a:schemeClr val="accent1"/>
+          </a:effectRef>
+          <a:fontRef idx="minor">
+            <a:schemeClr val="lt1"/>
+          </a:fontRef>
+        </p:style>
+        <p:txBody>
+          <a:bodyPr rtlCol="0" anchor="ctr" wrap="square" lIns="101600" rIns="101600" tIns="50800" bIns="50800"/>
+          <a:lstStyle/>
+          <a:p>
+            <a:pPr algn="ctr"/>
+            <a:r>
+              <a:rPr sz="1300" b="1">
+                <a:solidFill>
+                  <a:srgbClr val="18181B"/>
+                </a:solidFill>
+                <a:latin typeface="Microsoft JhengHei"/>
+                <a:ea typeface="Microsoft JhengHei"/>
+                <a:cs typeface="Microsoft JhengHei"/>
+              </a:rPr>
+              <a:t>使用者瀏覽器</a:t>
+            </a:r>
+          </a:p>
+          <a:p>
+            <a:pPr algn="ctr">
+              <a:lnSpc>
+                <a:spcPct val="100000"/>
+              </a:lnSpc>
+              <a:spcAft>
+                <a:spcPts val="0"/>
+              </a:spcAft>
+            </a:pPr>
+            <a:r>
+              <a:rPr sz="1050">
+                <a:solidFill>
+                  <a:srgbClr val="71717A"/>
+                </a:solidFill>
+                <a:latin typeface="Microsoft JhengHei"/>
+                <a:ea typeface="Microsoft JhengHei"/>
+                <a:cs typeface="Microsoft JhengHei"/>
+              </a:rPr>
+              <a:t>Browser</a:t>
+            </a:r>
+          </a:p>
+          <a:p>
+            <a:pPr algn="ctr">
+              <a:lnSpc>
+                <a:spcPct val="100000"/>
+              </a:lnSpc>
+              <a:spcAft>
+                <a:spcPts val="0"/>
+              </a:spcAft>
+            </a:pPr>
+            <a:r>
+              <a:rPr sz="1050">
+                <a:solidFill>
+                  <a:srgbClr val="71717A"/>
+                </a:solidFill>
+                <a:latin typeface="Microsoft JhengHei"/>
+                <a:ea typeface="Microsoft JhengHei"/>
+                <a:cs typeface="Microsoft JhengHei"/>
+              </a:rPr>
+              <a:t>桌機 / 行動裝置</a:t>
+            </a:r>
+          </a:p>
+        </p:txBody>
+      </p:sp>
+      <p:sp>
+        <p:nvSpPr>
+          <p:cNvPr id="8" name="Rounded Rectangle 7"/>
+          <p:cNvSpPr/>
+          <p:nvPr/>
+        </p:nvSpPr>
+        <p:spPr>
+          <a:xfrm>
+            <a:off x="3337560" y="2148840"/>
+            <a:ext cx="2331720" cy="1325880"/>
+          </a:xfrm>
+          <a:prstGeom prst="roundRect">
+            <a:avLst/>
+          </a:prstGeom>
+          <a:solidFill>
+            <a:srgbClr val="EFF6FF"/>
+          </a:solidFill>
+          <a:ln w="12700">
+            <a:solidFill>
+              <a:srgbClr val="93C5FD"/>
+            </a:solidFill>
+          </a:ln>
+          <a:effectLst/>
+        </p:spPr>
+        <p:style>
+          <a:lnRef idx="1">
+            <a:schemeClr val="accent1"/>
+          </a:lnRef>
+          <a:fillRef idx="3">
+            <a:schemeClr val="accent1"/>
+          </a:fillRef>
+          <a:effectRef idx="2">
+            <a:schemeClr val="accent1"/>
+          </a:effectRef>
+          <a:fontRef idx="minor">
+            <a:schemeClr val="lt1"/>
+          </a:fontRef>
+        </p:style>
+        <p:txBody>
+          <a:bodyPr rtlCol="0" anchor="ctr" wrap="square" lIns="101600" rIns="101600" tIns="50800" bIns="50800"/>
+          <a:lstStyle/>
+          <a:p>
+            <a:pPr algn="ctr"/>
+            <a:r>
+              <a:rPr sz="1300" b="1">
+                <a:solidFill>
+                  <a:srgbClr val="18181B"/>
+                </a:solidFill>
+                <a:latin typeface="Microsoft JhengHei"/>
+                <a:ea typeface="Microsoft JhengHei"/>
+                <a:cs typeface="Microsoft JhengHei"/>
+              </a:rPr>
+              <a:t>前端 Frontend</a:t>
+            </a:r>
+          </a:p>
+          <a:p>
+            <a:pPr algn="ctr">
+              <a:lnSpc>
+                <a:spcPct val="100000"/>
+              </a:lnSpc>
+              <a:spcAft>
+                <a:spcPts val="0"/>
+              </a:spcAft>
+            </a:pPr>
+            <a:r>
+              <a:rPr sz="1050">
+                <a:solidFill>
+                  <a:srgbClr val="71717A"/>
+                </a:solidFill>
+                <a:latin typeface="Microsoft JhengHei"/>
+                <a:ea typeface="Microsoft JhengHei"/>
+                <a:cs typeface="Microsoft JhengHei"/>
+              </a:rPr>
+              <a:t>Vercel</a:t>
+            </a:r>
+          </a:p>
+          <a:p>
+            <a:pPr algn="ctr">
+              <a:lnSpc>
+                <a:spcPct val="100000"/>
+              </a:lnSpc>
+              <a:spcAft>
+                <a:spcPts val="0"/>
+              </a:spcAft>
+            </a:pPr>
+            <a:r>
+              <a:rPr sz="1050">
+                <a:solidFill>
+                  <a:srgbClr val="71717A"/>
+                </a:solidFill>
+                <a:latin typeface="Microsoft JhengHei"/>
+                <a:ea typeface="Microsoft JhengHei"/>
+                <a:cs typeface="Microsoft JhengHei"/>
+              </a:rPr>
+              <a:t>Next.js 16 · React 19</a:t>
+            </a:r>
+          </a:p>
+          <a:p>
+            <a:pPr algn="ctr">
+              <a:lnSpc>
+                <a:spcPct val="100000"/>
+              </a:lnSpc>
+              <a:spcAft>
+                <a:spcPts val="0"/>
+              </a:spcAft>
+            </a:pPr>
+            <a:r>
+              <a:rPr sz="1050">
+                <a:solidFill>
+                  <a:srgbClr val="71717A"/>
+                </a:solidFill>
+                <a:latin typeface="Microsoft JhengHei"/>
+                <a:ea typeface="Microsoft JhengHei"/>
+                <a:cs typeface="Microsoft JhengHei"/>
+              </a:rPr>
+              <a:t>TypeScript · Tailwind 4</a:t>
+            </a:r>
+          </a:p>
+          <a:p>
+            <a:pPr algn="ctr">
+              <a:lnSpc>
+                <a:spcPct val="100000"/>
+              </a:lnSpc>
+              <a:spcAft>
+                <a:spcPts val="0"/>
+              </a:spcAft>
+            </a:pPr>
+            <a:r>
+              <a:rPr sz="1050">
+                <a:solidFill>
+                  <a:srgbClr val="71717A"/>
+                </a:solidFill>
+                <a:latin typeface="Microsoft JhengHei"/>
+                <a:ea typeface="Microsoft JhengHei"/>
+                <a:cs typeface="Microsoft JhengHei"/>
+              </a:rPr>
+              <a:t>Zustand</a:t>
+            </a:r>
+          </a:p>
+        </p:txBody>
+      </p:sp>
+      <p:sp>
+        <p:nvSpPr>
+          <p:cNvPr id="9" name="Rounded Rectangle 8"/>
+          <p:cNvSpPr/>
+          <p:nvPr/>
+        </p:nvSpPr>
+        <p:spPr>
+          <a:xfrm>
+            <a:off x="6035040" y="2148840"/>
+            <a:ext cx="2331720" cy="1325880"/>
+          </a:xfrm>
+          <a:prstGeom prst="roundRect">
+            <a:avLst/>
+          </a:prstGeom>
+          <a:solidFill>
+            <a:srgbClr val="ECFDF5"/>
+          </a:solidFill>
+          <a:ln w="12700">
+            <a:solidFill>
+              <a:srgbClr val="6EE7B7"/>
+            </a:solidFill>
+          </a:ln>
+          <a:effectLst/>
+        </p:spPr>
+        <p:style>
+          <a:lnRef idx="1">
+            <a:schemeClr val="accent1"/>
+          </a:lnRef>
+          <a:fillRef idx="3">
+            <a:schemeClr val="accent1"/>
+          </a:fillRef>
+          <a:effectRef idx="2">
+            <a:schemeClr val="accent1"/>
+          </a:effectRef>
+          <a:fontRef idx="minor">
+            <a:schemeClr val="lt1"/>
+          </a:fontRef>
+        </p:style>
+        <p:txBody>
+          <a:bodyPr rtlCol="0" anchor="ctr" wrap="square" lIns="101600" rIns="101600" tIns="50800" bIns="50800"/>
+          <a:lstStyle/>
+          <a:p>
+            <a:pPr algn="ctr"/>
+            <a:r>
+              <a:rPr sz="1300" b="1">
+                <a:solidFill>
+                  <a:srgbClr val="18181B"/>
+                </a:solidFill>
+                <a:latin typeface="Microsoft JhengHei"/>
+                <a:ea typeface="Microsoft JhengHei"/>
+                <a:cs typeface="Microsoft JhengHei"/>
+              </a:rPr>
+              <a:t>後端 Backend</a:t>
+            </a:r>
+          </a:p>
+          <a:p>
+            <a:pPr algn="ctr">
+              <a:lnSpc>
+                <a:spcPct val="100000"/>
+              </a:lnSpc>
+              <a:spcAft>
+                <a:spcPts val="0"/>
+              </a:spcAft>
+            </a:pPr>
+            <a:r>
+              <a:rPr sz="1050">
+                <a:solidFill>
+                  <a:srgbClr val="71717A"/>
+                </a:solidFill>
+                <a:latin typeface="Microsoft JhengHei"/>
+                <a:ea typeface="Microsoft JhengHei"/>
+                <a:cs typeface="Microsoft JhengHei"/>
+              </a:rPr>
+              <a:t>Render (Docker)</a:t>
+            </a:r>
+          </a:p>
+          <a:p>
+            <a:pPr algn="ctr">
+              <a:lnSpc>
+                <a:spcPct val="100000"/>
+              </a:lnSpc>
+              <a:spcAft>
+                <a:spcPts val="0"/>
+              </a:spcAft>
+            </a:pPr>
+            <a:r>
+              <a:rPr sz="1050">
+                <a:solidFill>
+                  <a:srgbClr val="71717A"/>
+                </a:solidFill>
+                <a:latin typeface="Microsoft JhengHei"/>
+                <a:ea typeface="Microsoft JhengHei"/>
+                <a:cs typeface="Microsoft JhengHei"/>
+              </a:rPr>
+              <a:t>Spring Boot 4 · Java 25</a:t>
+            </a:r>
+          </a:p>
+          <a:p>
+            <a:pPr algn="ctr">
+              <a:lnSpc>
+                <a:spcPct val="100000"/>
+              </a:lnSpc>
+              <a:spcAft>
+                <a:spcPts val="0"/>
+              </a:spcAft>
+            </a:pPr>
+            <a:r>
+              <a:rPr sz="1050">
+                <a:solidFill>
+                  <a:srgbClr val="71717A"/>
+                </a:solidFill>
+                <a:latin typeface="Microsoft JhengHei"/>
+                <a:ea typeface="Microsoft JhengHei"/>
+                <a:cs typeface="Microsoft JhengHei"/>
+              </a:rPr>
+              <a:t>Spring Security · JWT</a:t>
+            </a:r>
+          </a:p>
+        </p:txBody>
+      </p:sp>
+      <p:sp>
+        <p:nvSpPr>
+          <p:cNvPr id="10" name="Rounded Rectangle 9"/>
+          <p:cNvSpPr/>
+          <p:nvPr/>
+        </p:nvSpPr>
+        <p:spPr>
+          <a:xfrm>
+            <a:off x="8732520" y="2148840"/>
+            <a:ext cx="2331720" cy="1325880"/>
+          </a:xfrm>
+          <a:prstGeom prst="roundRect">
+            <a:avLst/>
+          </a:prstGeom>
+          <a:solidFill>
+            <a:srgbClr val="FEF3C7"/>
+          </a:solidFill>
+          <a:ln w="12700">
+            <a:solidFill>
+              <a:srgbClr val="FCD34D"/>
+            </a:solidFill>
+          </a:ln>
+          <a:effectLst/>
+        </p:spPr>
+        <p:style>
+          <a:lnRef idx="1">
+            <a:schemeClr val="accent1"/>
+          </a:lnRef>
+          <a:fillRef idx="3">
+            <a:schemeClr val="accent1"/>
+          </a:fillRef>
+          <a:effectRef idx="2">
+            <a:schemeClr val="accent1"/>
+          </a:effectRef>
+          <a:fontRef idx="minor">
+            <a:schemeClr val="lt1"/>
+          </a:fontRef>
+        </p:style>
+        <p:txBody>
+          <a:bodyPr rtlCol="0" anchor="ctr" wrap="square" lIns="101600" rIns="101600" tIns="50800" bIns="50800"/>
+          <a:lstStyle/>
+          <a:p>
+            <a:pPr algn="ctr"/>
+            <a:r>
+              <a:rPr sz="1300" b="1">
+                <a:solidFill>
+                  <a:srgbClr val="18181B"/>
+                </a:solidFill>
+                <a:latin typeface="Microsoft JhengHei"/>
+                <a:ea typeface="Microsoft JhengHei"/>
+                <a:cs typeface="Microsoft JhengHei"/>
+              </a:rPr>
+              <a:t>資料庫 Database</a:t>
+            </a:r>
+          </a:p>
+          <a:p>
+            <a:pPr algn="ctr">
+              <a:lnSpc>
+                <a:spcPct val="100000"/>
+              </a:lnSpc>
+              <a:spcAft>
+                <a:spcPts val="0"/>
+              </a:spcAft>
+            </a:pPr>
+            <a:r>
+              <a:rPr sz="1050">
+                <a:solidFill>
+                  <a:srgbClr val="71717A"/>
+                </a:solidFill>
+                <a:latin typeface="Microsoft JhengHei"/>
+                <a:ea typeface="Microsoft JhengHei"/>
+                <a:cs typeface="Microsoft JhengHei"/>
+              </a:rPr>
+              <a:t>TiDB Cloud Serverless</a:t>
+            </a:r>
+          </a:p>
+          <a:p>
+            <a:pPr algn="ctr">
+              <a:lnSpc>
+                <a:spcPct val="100000"/>
+              </a:lnSpc>
+              <a:spcAft>
+                <a:spcPts val="0"/>
+              </a:spcAft>
+            </a:pPr>
+            <a:r>
+              <a:rPr sz="1050">
+                <a:solidFill>
+                  <a:srgbClr val="71717A"/>
+                </a:solidFill>
+                <a:latin typeface="Microsoft JhengHei"/>
+                <a:ea typeface="Microsoft JhengHei"/>
+                <a:cs typeface="Microsoft JhengHei"/>
+              </a:rPr>
+              <a:t>(MySQL 相容)</a:t>
+            </a:r>
+          </a:p>
+          <a:p>
+            <a:pPr algn="ctr">
+              <a:lnSpc>
+                <a:spcPct val="100000"/>
+              </a:lnSpc>
+              <a:spcAft>
+                <a:spcPts val="0"/>
+              </a:spcAft>
+            </a:pPr>
+            <a:r>
+              <a:rPr sz="1050">
+                <a:solidFill>
+                  <a:srgbClr val="71717A"/>
+                </a:solidFill>
+                <a:latin typeface="Microsoft JhengHei"/>
+                <a:ea typeface="Microsoft JhengHei"/>
+                <a:cs typeface="Microsoft JhengHei"/>
+              </a:rPr>
+              <a:t>本地開發用 MySQL 8</a:t>
+            </a:r>
+          </a:p>
+        </p:txBody>
+      </p:sp>
+      <p:sp>
+        <p:nvSpPr>
+          <p:cNvPr id="11" name="TextBox 10"/>
+          <p:cNvSpPr txBox="1"/>
+          <p:nvPr/>
+        </p:nvSpPr>
+        <p:spPr>
+          <a:xfrm>
+            <a:off x="3017520" y="2148840"/>
+            <a:ext cx="320040" cy="1325880"/>
+          </a:xfrm>
+          <a:prstGeom prst="rect">
+            <a:avLst/>
+          </a:prstGeom>
+          <a:noFill/>
+        </p:spPr>
+        <p:txBody>
+          <a:bodyPr wrap="square" anchor="ctr">
+            <a:spAutoFit/>
+          </a:bodyPr>
+          <a:lstStyle/>
+          <a:p>
+            <a:pPr algn="ctr">
+              <a:lnSpc>
+                <a:spcPct val="105000"/>
+              </a:lnSpc>
+              <a:spcBef>
+                <a:spcPts val="0"/>
+              </a:spcBef>
+              <a:spcAft>
+                <a:spcPts val="200"/>
+              </a:spcAft>
+            </a:pPr>
+            <a:r>
+              <a:rPr sz="2000" b="1">
+                <a:solidFill>
+                  <a:srgbClr val="2563EB"/>
+                </a:solidFill>
+                <a:latin typeface="Microsoft JhengHei"/>
+                <a:ea typeface="Microsoft JhengHei"/>
+                <a:cs typeface="Microsoft JhengHei"/>
+              </a:rPr>
+              <a:t>→</a:t>
+            </a:r>
+          </a:p>
+        </p:txBody>
+      </p:sp>
+      <p:sp>
+        <p:nvSpPr>
+          <p:cNvPr id="12" name="TextBox 11"/>
+          <p:cNvSpPr txBox="1"/>
+          <p:nvPr/>
+        </p:nvSpPr>
+        <p:spPr>
+          <a:xfrm>
+            <a:off x="5715000" y="2148840"/>
+            <a:ext cx="320040" cy="1325880"/>
+          </a:xfrm>
+          <a:prstGeom prst="rect">
+            <a:avLst/>
+          </a:prstGeom>
+          <a:noFill/>
+        </p:spPr>
+        <p:txBody>
+          <a:bodyPr wrap="square" anchor="ctr">
+            <a:spAutoFit/>
+          </a:bodyPr>
+          <a:lstStyle/>
+          <a:p>
+            <a:pPr algn="ctr">
+              <a:lnSpc>
+                <a:spcPct val="105000"/>
+              </a:lnSpc>
+              <a:spcBef>
+                <a:spcPts val="0"/>
+              </a:spcBef>
+              <a:spcAft>
+                <a:spcPts val="200"/>
+              </a:spcAft>
+            </a:pPr>
+            <a:r>
+              <a:rPr sz="2000" b="1">
+                <a:solidFill>
+                  <a:srgbClr val="2563EB"/>
+                </a:solidFill>
+                <a:latin typeface="Microsoft JhengHei"/>
+                <a:ea typeface="Microsoft JhengHei"/>
+                <a:cs typeface="Microsoft JhengHei"/>
+              </a:rPr>
+              <a:t>→</a:t>
+            </a:r>
+          </a:p>
+        </p:txBody>
+      </p:sp>
+      <p:sp>
+        <p:nvSpPr>
+          <p:cNvPr id="13" name="TextBox 12"/>
+          <p:cNvSpPr txBox="1"/>
+          <p:nvPr/>
+        </p:nvSpPr>
+        <p:spPr>
+          <a:xfrm>
+            <a:off x="8412480" y="2148840"/>
+            <a:ext cx="320040" cy="1325880"/>
+          </a:xfrm>
+          <a:prstGeom prst="rect">
+            <a:avLst/>
+          </a:prstGeom>
+          <a:noFill/>
+        </p:spPr>
+        <p:txBody>
+          <a:bodyPr wrap="square" anchor="ctr">
+            <a:spAutoFit/>
+          </a:bodyPr>
+          <a:lstStyle/>
+          <a:p>
+            <a:pPr algn="ctr">
+              <a:lnSpc>
+                <a:spcPct val="105000"/>
+              </a:lnSpc>
+              <a:spcBef>
+                <a:spcPts val="0"/>
+              </a:spcBef>
+              <a:spcAft>
+                <a:spcPts val="200"/>
+              </a:spcAft>
+            </a:pPr>
+            <a:r>
+              <a:rPr sz="2000" b="1">
+                <a:solidFill>
+                  <a:srgbClr val="2563EB"/>
+                </a:solidFill>
+                <a:latin typeface="Microsoft JhengHei"/>
+                <a:ea typeface="Microsoft JhengHei"/>
+                <a:cs typeface="Microsoft JhengHei"/>
+              </a:rPr>
+              <a:t>→</a:t>
+            </a:r>
+          </a:p>
+        </p:txBody>
+      </p:sp>
+      <p:sp>
+        <p:nvSpPr>
+          <p:cNvPr id="14" name="TextBox 13"/>
+          <p:cNvSpPr txBox="1"/>
+          <p:nvPr/>
+        </p:nvSpPr>
+        <p:spPr>
+          <a:xfrm>
+            <a:off x="3337560" y="3493008"/>
+            <a:ext cx="5394960" cy="274320"/>
+          </a:xfrm>
+          <a:prstGeom prst="rect">
+            <a:avLst/>
+          </a:prstGeom>
+          <a:noFill/>
+        </p:spPr>
+        <p:txBody>
+          <a:bodyPr wrap="square" anchor="t">
+            <a:spAutoFit/>
+          </a:bodyPr>
+          <a:lstStyle/>
+          <a:p>
+            <a:pPr algn="ctr">
+              <a:lnSpc>
+                <a:spcPct val="105000"/>
+              </a:lnSpc>
+              <a:spcBef>
+                <a:spcPts val="0"/>
+              </a:spcBef>
+              <a:spcAft>
+                <a:spcPts val="200"/>
+              </a:spcAft>
+            </a:pPr>
+            <a:r>
+              <a:rPr sz="900" b="0">
+                <a:solidFill>
+                  <a:srgbClr val="71717A"/>
+                </a:solidFill>
+                <a:latin typeface="Microsoft JhengHei"/>
+                <a:ea typeface="Microsoft JhengHei"/>
+                <a:cs typeface="Microsoft JhengHei"/>
+              </a:rPr>
+              <a:t>HTTPS · REST / JSON · JWT</a:t>
+            </a:r>
+          </a:p>
+        </p:txBody>
+      </p:sp>
+      <p:sp>
+        <p:nvSpPr>
+          <p:cNvPr id="15" name="TextBox 14"/>
+          <p:cNvSpPr txBox="1"/>
+          <p:nvPr/>
+        </p:nvSpPr>
+        <p:spPr>
+          <a:xfrm>
+            <a:off x="7018020" y="3429000"/>
+            <a:ext cx="365760" cy="502920"/>
+          </a:xfrm>
+          <a:prstGeom prst="rect">
+            <a:avLst/>
+          </a:prstGeom>
+          <a:noFill/>
+        </p:spPr>
+        <p:txBody>
+          <a:bodyPr wrap="square" anchor="ctr">
+            <a:spAutoFit/>
+          </a:bodyPr>
+          <a:lstStyle/>
+          <a:p>
+            <a:pPr algn="ctr">
+              <a:lnSpc>
+                <a:spcPct val="105000"/>
+              </a:lnSpc>
+              <a:spcBef>
+                <a:spcPts val="0"/>
+              </a:spcBef>
+              <a:spcAft>
+                <a:spcPts val="200"/>
+              </a:spcAft>
+            </a:pPr>
+            <a:r>
+              <a:rPr sz="1800" b="1">
+                <a:solidFill>
+                  <a:srgbClr val="2563EB"/>
+                </a:solidFill>
+                <a:latin typeface="Microsoft JhengHei"/>
+                <a:ea typeface="Microsoft JhengHei"/>
+                <a:cs typeface="Microsoft JhengHei"/>
+              </a:rPr>
+              <a:t>↓</a:t>
+            </a:r>
+          </a:p>
+        </p:txBody>
+      </p:sp>
+      <p:sp>
+        <p:nvSpPr>
+          <p:cNvPr id="16" name="Rounded Rectangle 15"/>
+          <p:cNvSpPr/>
+          <p:nvPr/>
+        </p:nvSpPr>
+        <p:spPr>
+          <a:xfrm>
+            <a:off x="640080" y="4069080"/>
+            <a:ext cx="10424160" cy="1234440"/>
+          </a:xfrm>
+          <a:prstGeom prst="roundRect">
+            <a:avLst/>
+          </a:prstGeom>
+          <a:solidFill>
+            <a:srgbClr val="FFFFFF"/>
+          </a:solidFill>
+          <a:ln w="12700">
+            <a:solidFill>
+              <a:srgbClr val="E4E4E7"/>
+            </a:solidFill>
+          </a:ln>
+          <a:effectLst/>
+        </p:spPr>
+        <p:style>
+          <a:lnRef idx="1">
+            <a:schemeClr val="accent1"/>
+          </a:lnRef>
+          <a:fillRef idx="3">
+            <a:schemeClr val="accent1"/>
+          </a:fillRef>
+          <a:effectRef idx="2">
+            <a:schemeClr val="accent1"/>
+          </a:effectRef>
+          <a:fontRef idx="minor">
+            <a:schemeClr val="lt1"/>
+          </a:fontRef>
+        </p:style>
+        <p:txBody>
+          <a:bodyPr rtlCol="0" anchor="ctr" wrap="square" lIns="101600" rIns="101600" tIns="50800" bIns="50800"/>
+          <a:lstStyle/>
+          <a:p>
+            <a:pPr algn="ctr"/>
+            <a:r>
+              <a:rPr sz="1300" b="1">
+                <a:solidFill>
+                  <a:srgbClr val="18181B"/>
+                </a:solidFill>
+                <a:latin typeface="Microsoft JhengHei"/>
+                <a:ea typeface="Microsoft JhengHei"/>
+                <a:cs typeface="Microsoft JhengHei"/>
+              </a:rPr>
+              <a:t>外部整合 External integrations</a:t>
+            </a:r>
+          </a:p>
+        </p:txBody>
+      </p:sp>
+      <p:sp>
+        <p:nvSpPr>
+          <p:cNvPr id="17" name="Rounded Rectangle 16"/>
+          <p:cNvSpPr/>
+          <p:nvPr/>
+        </p:nvSpPr>
+        <p:spPr>
+          <a:xfrm>
+            <a:off x="868680" y="4480560"/>
+            <a:ext cx="1938528" cy="713232"/>
+          </a:xfrm>
+          <a:prstGeom prst="roundRect">
+            <a:avLst/>
+          </a:prstGeom>
+          <a:solidFill>
+            <a:srgbClr val="F4F4F5"/>
+          </a:solidFill>
+          <a:ln w="12700">
+            <a:solidFill>
+              <a:srgbClr val="E4E4E7"/>
+            </a:solidFill>
+          </a:ln>
+          <a:effectLst/>
+        </p:spPr>
+        <p:style>
+          <a:lnRef idx="1">
+            <a:schemeClr val="accent1"/>
+          </a:lnRef>
+          <a:fillRef idx="3">
+            <a:schemeClr val="accent1"/>
+          </a:fillRef>
+          <a:effectRef idx="2">
+            <a:schemeClr val="accent1"/>
+          </a:effectRef>
+          <a:fontRef idx="minor">
+            <a:schemeClr val="lt1"/>
+          </a:fontRef>
+        </p:style>
+        <p:txBody>
+          <a:bodyPr rtlCol="0" anchor="ctr" wrap="square" lIns="101600" rIns="101600" tIns="50800" bIns="50800"/>
+          <a:lstStyle/>
+          <a:p>
+            <a:pPr algn="ctr"/>
+            <a:r>
+              <a:rPr sz="1050" b="1">
+                <a:solidFill>
+                  <a:srgbClr val="18181B"/>
+                </a:solidFill>
+                <a:latin typeface="Microsoft JhengHei"/>
+                <a:ea typeface="Microsoft JhengHei"/>
+                <a:cs typeface="Microsoft JhengHei"/>
+              </a:rPr>
+              <a:t>arXiv Atom API</a:t>
+            </a:r>
+          </a:p>
+          <a:p>
+            <a:pPr algn="ctr">
+              <a:lnSpc>
+                <a:spcPct val="100000"/>
+              </a:lnSpc>
+              <a:spcAft>
+                <a:spcPts val="0"/>
+              </a:spcAft>
+            </a:pPr>
+            <a:r>
+              <a:rPr sz="900">
+                <a:solidFill>
+                  <a:srgbClr val="71717A"/>
+                </a:solidFill>
+                <a:latin typeface="Microsoft JhengHei"/>
+                <a:ea typeface="Microsoft JhengHei"/>
+                <a:cs typeface="Microsoft JhengHei"/>
+              </a:rPr>
+              <a:t>論文同步</a:t>
+            </a:r>
+          </a:p>
+        </p:txBody>
+      </p:sp>
+      <p:sp>
+        <p:nvSpPr>
+          <p:cNvPr id="18" name="Rounded Rectangle 17"/>
+          <p:cNvSpPr/>
+          <p:nvPr/>
+        </p:nvSpPr>
+        <p:spPr>
+          <a:xfrm>
+            <a:off x="2916936" y="4480560"/>
+            <a:ext cx="1938528" cy="713232"/>
+          </a:xfrm>
+          <a:prstGeom prst="roundRect">
+            <a:avLst/>
+          </a:prstGeom>
+          <a:solidFill>
+            <a:srgbClr val="F4F4F5"/>
+          </a:solidFill>
+          <a:ln w="12700">
+            <a:solidFill>
+              <a:srgbClr val="E4E4E7"/>
+            </a:solidFill>
+          </a:ln>
+          <a:effectLst/>
+        </p:spPr>
+        <p:style>
+          <a:lnRef idx="1">
+            <a:schemeClr val="accent1"/>
+          </a:lnRef>
+          <a:fillRef idx="3">
+            <a:schemeClr val="accent1"/>
+          </a:fillRef>
+          <a:effectRef idx="2">
+            <a:schemeClr val="accent1"/>
+          </a:effectRef>
+          <a:fontRef idx="minor">
+            <a:schemeClr val="lt1"/>
+          </a:fontRef>
+        </p:style>
+        <p:txBody>
+          <a:bodyPr rtlCol="0" anchor="ctr" wrap="square" lIns="101600" rIns="101600" tIns="50800" bIns="50800"/>
+          <a:lstStyle/>
+          <a:p>
+            <a:pPr algn="ctr"/>
+            <a:r>
+              <a:rPr sz="1050" b="1">
+                <a:solidFill>
+                  <a:srgbClr val="18181B"/>
+                </a:solidFill>
+                <a:latin typeface="Microsoft JhengHei"/>
+                <a:ea typeface="Microsoft JhengHei"/>
+                <a:cs typeface="Microsoft JhengHei"/>
+              </a:rPr>
+              <a:t>HBR RSS</a:t>
+            </a:r>
+          </a:p>
+          <a:p>
+            <a:pPr algn="ctr">
+              <a:lnSpc>
+                <a:spcPct val="100000"/>
+              </a:lnSpc>
+              <a:spcAft>
+                <a:spcPts val="0"/>
+              </a:spcAft>
+            </a:pPr>
+            <a:r>
+              <a:rPr sz="900">
+                <a:solidFill>
+                  <a:srgbClr val="71717A"/>
+                </a:solidFill>
+                <a:latin typeface="Microsoft JhengHei"/>
+                <a:ea typeface="Microsoft JhengHei"/>
+                <a:cs typeface="Microsoft JhengHei"/>
+              </a:rPr>
+              <a:t>文章來源</a:t>
+            </a:r>
+          </a:p>
+        </p:txBody>
+      </p:sp>
+      <p:sp>
+        <p:nvSpPr>
+          <p:cNvPr id="19" name="Rounded Rectangle 18"/>
+          <p:cNvSpPr/>
+          <p:nvPr/>
+        </p:nvSpPr>
+        <p:spPr>
+          <a:xfrm>
+            <a:off x="4965192" y="4480560"/>
+            <a:ext cx="1938528" cy="713232"/>
+          </a:xfrm>
+          <a:prstGeom prst="roundRect">
+            <a:avLst/>
+          </a:prstGeom>
+          <a:solidFill>
+            <a:srgbClr val="F4F4F5"/>
+          </a:solidFill>
+          <a:ln w="12700">
+            <a:solidFill>
+              <a:srgbClr val="E4E4E7"/>
+            </a:solidFill>
+          </a:ln>
+          <a:effectLst/>
+        </p:spPr>
+        <p:style>
+          <a:lnRef idx="1">
+            <a:schemeClr val="accent1"/>
+          </a:lnRef>
+          <a:fillRef idx="3">
+            <a:schemeClr val="accent1"/>
+          </a:fillRef>
+          <a:effectRef idx="2">
+            <a:schemeClr val="accent1"/>
+          </a:effectRef>
+          <a:fontRef idx="minor">
+            <a:schemeClr val="lt1"/>
+          </a:fontRef>
+        </p:style>
+        <p:txBody>
+          <a:bodyPr rtlCol="0" anchor="ctr" wrap="square" lIns="101600" rIns="101600" tIns="50800" bIns="50800"/>
+          <a:lstStyle/>
+          <a:p>
+            <a:pPr algn="ctr"/>
+            <a:r>
+              <a:rPr sz="1050" b="1">
+                <a:solidFill>
+                  <a:srgbClr val="18181B"/>
+                </a:solidFill>
+                <a:latin typeface="Microsoft JhengHei"/>
+                <a:ea typeface="Microsoft JhengHei"/>
+                <a:cs typeface="Microsoft JhengHei"/>
+              </a:rPr>
+              <a:t>Google Gemini 2.5 Flash</a:t>
+            </a:r>
+          </a:p>
+          <a:p>
+            <a:pPr algn="ctr">
+              <a:lnSpc>
+                <a:spcPct val="100000"/>
+              </a:lnSpc>
+              <a:spcAft>
+                <a:spcPts val="0"/>
+              </a:spcAft>
+            </a:pPr>
+            <a:r>
+              <a:rPr sz="900">
+                <a:solidFill>
+                  <a:srgbClr val="71717A"/>
+                </a:solidFill>
+                <a:latin typeface="Microsoft JhengHei"/>
+                <a:ea typeface="Microsoft JhengHei"/>
+                <a:cs typeface="Microsoft JhengHei"/>
+              </a:rPr>
+              <a:t>摘要 / 翻譯</a:t>
+            </a:r>
+          </a:p>
+        </p:txBody>
+      </p:sp>
+      <p:sp>
+        <p:nvSpPr>
+          <p:cNvPr id="20" name="Rounded Rectangle 19"/>
+          <p:cNvSpPr/>
+          <p:nvPr/>
+        </p:nvSpPr>
+        <p:spPr>
+          <a:xfrm>
+            <a:off x="7013448" y="4480560"/>
+            <a:ext cx="1938528" cy="713232"/>
+          </a:xfrm>
+          <a:prstGeom prst="roundRect">
+            <a:avLst/>
+          </a:prstGeom>
+          <a:solidFill>
+            <a:srgbClr val="F4F4F5"/>
+          </a:solidFill>
+          <a:ln w="12700">
+            <a:solidFill>
+              <a:srgbClr val="E4E4E7"/>
+            </a:solidFill>
+          </a:ln>
+          <a:effectLst/>
+        </p:spPr>
+        <p:style>
+          <a:lnRef idx="1">
+            <a:schemeClr val="accent1"/>
+          </a:lnRef>
+          <a:fillRef idx="3">
+            <a:schemeClr val="accent1"/>
+          </a:fillRef>
+          <a:effectRef idx="2">
+            <a:schemeClr val="accent1"/>
+          </a:effectRef>
+          <a:fontRef idx="minor">
+            <a:schemeClr val="lt1"/>
+          </a:fontRef>
+        </p:style>
+        <p:txBody>
+          <a:bodyPr rtlCol="0" anchor="ctr" wrap="square" lIns="101600" rIns="101600" tIns="50800" bIns="50800"/>
+          <a:lstStyle/>
+          <a:p>
+            <a:pPr algn="ctr"/>
+            <a:r>
+              <a:rPr sz="1050" b="1">
+                <a:solidFill>
+                  <a:srgbClr val="18181B"/>
+                </a:solidFill>
+                <a:latin typeface="Microsoft JhengHei"/>
+                <a:ea typeface="Microsoft JhengHei"/>
+                <a:cs typeface="Microsoft JhengHei"/>
+              </a:rPr>
+              <a:t>Resend</a:t>
+            </a:r>
+          </a:p>
+          <a:p>
+            <a:pPr algn="ctr">
+              <a:lnSpc>
+                <a:spcPct val="100000"/>
+              </a:lnSpc>
+              <a:spcAft>
+                <a:spcPts val="0"/>
+              </a:spcAft>
+            </a:pPr>
+            <a:r>
+              <a:rPr sz="900">
+                <a:solidFill>
+                  <a:srgbClr val="71717A"/>
+                </a:solidFill>
+                <a:latin typeface="Microsoft JhengHei"/>
+                <a:ea typeface="Microsoft JhengHei"/>
+                <a:cs typeface="Microsoft JhengHei"/>
+              </a:rPr>
+              <a:t>Email 通知</a:t>
+            </a:r>
+          </a:p>
+        </p:txBody>
+      </p:sp>
+      <p:sp>
+        <p:nvSpPr>
+          <p:cNvPr id="21" name="Rounded Rectangle 20"/>
+          <p:cNvSpPr/>
+          <p:nvPr/>
+        </p:nvSpPr>
+        <p:spPr>
+          <a:xfrm>
+            <a:off x="9061704" y="4480560"/>
+            <a:ext cx="1938528" cy="713232"/>
+          </a:xfrm>
+          <a:prstGeom prst="roundRect">
+            <a:avLst/>
+          </a:prstGeom>
+          <a:solidFill>
+            <a:srgbClr val="F4F4F5"/>
+          </a:solidFill>
+          <a:ln w="12700">
+            <a:solidFill>
+              <a:srgbClr val="E4E4E7"/>
+            </a:solidFill>
+          </a:ln>
+          <a:effectLst/>
+        </p:spPr>
+        <p:style>
+          <a:lnRef idx="1">
+            <a:schemeClr val="accent1"/>
+          </a:lnRef>
+          <a:fillRef idx="3">
+            <a:schemeClr val="accent1"/>
+          </a:fillRef>
+          <a:effectRef idx="2">
+            <a:schemeClr val="accent1"/>
+          </a:effectRef>
+          <a:fontRef idx="minor">
+            <a:schemeClr val="lt1"/>
+          </a:fontRef>
+        </p:style>
+        <p:txBody>
+          <a:bodyPr rtlCol="0" anchor="ctr" wrap="square" lIns="101600" rIns="101600" tIns="50800" bIns="50800"/>
+          <a:lstStyle/>
+          <a:p>
+            <a:pPr algn="ctr"/>
+            <a:r>
+              <a:rPr sz="1050" b="1">
+                <a:solidFill>
+                  <a:srgbClr val="18181B"/>
+                </a:solidFill>
+                <a:latin typeface="Microsoft JhengHei"/>
+                <a:ea typeface="Microsoft JhengHei"/>
+                <a:cs typeface="Microsoft JhengHei"/>
+              </a:rPr>
+              <a:t>GitHub Actions</a:t>
+            </a:r>
+          </a:p>
+          <a:p>
+            <a:pPr algn="ctr">
+              <a:lnSpc>
+                <a:spcPct val="100000"/>
+              </a:lnSpc>
+              <a:spcAft>
+                <a:spcPts val="0"/>
+              </a:spcAft>
+            </a:pPr>
+            <a:r>
+              <a:rPr sz="900">
+                <a:solidFill>
+                  <a:srgbClr val="71717A"/>
+                </a:solidFill>
+                <a:latin typeface="Microsoft JhengHei"/>
+                <a:ea typeface="Microsoft JhengHei"/>
+                <a:cs typeface="Microsoft JhengHei"/>
+              </a:rPr>
+              <a:t>每 6 小時 cron</a:t>
+            </a:r>
+          </a:p>
+        </p:txBody>
+      </p:sp>
+      <p:sp>
+        <p:nvSpPr>
+          <p:cNvPr id="22" name="TextBox 21"/>
+          <p:cNvSpPr txBox="1"/>
+          <p:nvPr/>
+        </p:nvSpPr>
+        <p:spPr>
+          <a:xfrm>
+            <a:off x="640080" y="6355080"/>
+            <a:ext cx="10789920" cy="365760"/>
+          </a:xfrm>
+          <a:prstGeom prst="rect">
+            <a:avLst/>
+          </a:prstGeom>
+          <a:noFill/>
+        </p:spPr>
+        <p:txBody>
+          <a:bodyPr wrap="square" anchor="t">
+            <a:spAutoFit/>
+          </a:bodyPr>
+          <a:lstStyle/>
+          <a:p>
+            <a:pPr algn="l">
+              <a:lnSpc>
+                <a:spcPct val="105000"/>
+              </a:lnSpc>
+              <a:spcBef>
+                <a:spcPts val="0"/>
+              </a:spcBef>
+              <a:spcAft>
+                <a:spcPts val="200"/>
+              </a:spcAft>
+            </a:pPr>
+            <a:r>
+              <a:rPr sz="1050" b="0">
+                <a:solidFill>
+                  <a:srgbClr val="71717A"/>
+                </a:solidFill>
+                <a:latin typeface="Microsoft JhengHei"/>
+                <a:ea typeface="Microsoft JhengHei"/>
+                <a:cs typeface="Microsoft JhengHei"/>
+              </a:rPr>
+              <a:t>部署：Vercel（前端）· Render（後端）· TiDB Cloud（資料庫）— 全部免費方案</a:t>
+            </a:r>
+          </a:p>
+        </p:txBody>
+      </p:sp>
+    </p:spTree>
+  </p:cSld>
+  <p:clrMapOvr>
+    <a:masterClrMapping/>
+  </p:clrMapOvr>
+</p:sld>
+</file>
+
+<file path=ppt/slides/slide3.xml><?xml version="1.0" encoding="utf-8"?>
+<p:sld xmlns:a="http://schemas.openxmlformats.org/drawingml/2006/main" xmlns:p="http://schemas.openxmlformats.org/presentationml/2006/main" xmlns:r="http://schemas.openxmlformats.org/officeDocument/2006/relationships">
+  <p:cSld>
+    <p:spTree>
+      <p:nvGrpSpPr>
+        <p:cNvPr id="1" name=""/>
+        <p:cNvGrpSpPr/>
+        <p:nvPr/>
+      </p:nvGrpSpPr>
+      <p:grpSpPr/>
+      <p:sp>
+        <p:nvSpPr>
+          <p:cNvPr id="2" name="Rectangle 1"/>
+          <p:cNvSpPr/>
+          <p:nvPr/>
+        </p:nvSpPr>
+        <p:spPr>
+          <a:xfrm>
+            <a:off x="0" y="0"/>
+            <a:ext cx="12191695" cy="6858000"/>
+          </a:xfrm>
+          <a:prstGeom prst="rect">
+            <a:avLst/>
+          </a:prstGeom>
+          <a:solidFill>
+            <a:srgbClr val="FFFFFF"/>
+          </a:solidFill>
+          <a:ln>
+            <a:noFill/>
+          </a:ln>
+          <a:effectLst/>
+        </p:spPr>
+        <p:style>
+          <a:lnRef idx="1">
+            <a:schemeClr val="accent1"/>
+          </a:lnRef>
+          <a:fillRef idx="3">
+            <a:schemeClr val="accent1"/>
+          </a:fillRef>
+          <a:effectRef idx="2">
+            <a:schemeClr val="accent1"/>
+          </a:effectRef>
+          <a:fontRef idx="minor">
+            <a:schemeClr val="lt1"/>
+          </a:fontRef>
+        </p:style>
+        <p:txBody>
+          <a:bodyPr rtlCol="0" anchor="ctr"/>
+          <a:lstStyle/>
+          <a:p>
+            <a:pPr algn="ctr"/>
+          </a:p>
+        </p:txBody>
+      </p:sp>
+      <p:sp>
+        <p:nvSpPr>
+          <p:cNvPr id="3" name="Rectangle 2"/>
+          <p:cNvSpPr/>
+          <p:nvPr/>
+        </p:nvSpPr>
+        <p:spPr>
+          <a:xfrm>
+            <a:off x="548640" y="502920"/>
+            <a:ext cx="109728" cy="566928"/>
+          </a:xfrm>
+          <a:prstGeom prst="rect">
+            <a:avLst/>
+          </a:prstGeom>
+          <a:solidFill>
+            <a:srgbClr val="2563EB"/>
+          </a:solidFill>
+          <a:ln>
+            <a:noFill/>
+          </a:ln>
+          <a:effectLst/>
+        </p:spPr>
+        <p:style>
+          <a:lnRef idx="1">
+            <a:schemeClr val="accent1"/>
+          </a:lnRef>
+          <a:fillRef idx="3">
+            <a:schemeClr val="accent1"/>
+          </a:fillRef>
+          <a:effectRef idx="2">
+            <a:schemeClr val="accent1"/>
+          </a:effectRef>
+          <a:fontRef idx="minor">
+            <a:schemeClr val="lt1"/>
+          </a:fontRef>
+        </p:style>
+        <p:txBody>
+          <a:bodyPr rtlCol="0" anchor="ctr"/>
+          <a:lstStyle/>
+          <a:p>
+            <a:pPr algn="ctr"/>
+          </a:p>
+        </p:txBody>
+      </p:sp>
+      <p:sp>
+        <p:nvSpPr>
+          <p:cNvPr id="4" name="TextBox 3"/>
+          <p:cNvSpPr txBox="1"/>
+          <p:nvPr/>
+        </p:nvSpPr>
+        <p:spPr>
+          <a:xfrm>
+            <a:off x="777240" y="411480"/>
+            <a:ext cx="9601200" cy="914400"/>
+          </a:xfrm>
+          <a:prstGeom prst="rect">
+            <a:avLst/>
+          </a:prstGeom>
+          <a:noFill/>
+        </p:spPr>
+        <p:txBody>
+          <a:bodyPr wrap="square" anchor="t">
+            <a:spAutoFit/>
+          </a:bodyPr>
+          <a:lstStyle/>
+          <a:p>
+            <a:pPr algn="l">
+              <a:lnSpc>
+                <a:spcPct val="105000"/>
+              </a:lnSpc>
+              <a:spcBef>
+                <a:spcPts val="0"/>
+              </a:spcBef>
+              <a:spcAft>
+                <a:spcPts val="200"/>
+              </a:spcAft>
+            </a:pPr>
+            <a:r>
+              <a:rPr sz="2600" b="1">
+                <a:solidFill>
+                  <a:srgbClr val="18181B"/>
+                </a:solidFill>
+                <a:latin typeface="Microsoft JhengHei"/>
+                <a:ea typeface="Microsoft JhengHei"/>
+                <a:cs typeface="Microsoft JhengHei"/>
+              </a:rPr>
+              <a:t>系統特色  </a:t>
+            </a:r>
+            <a:r>
+              <a:rPr sz="1500" b="0">
+                <a:solidFill>
+                  <a:srgbClr val="71717A"/>
+                </a:solidFill>
+                <a:latin typeface="Microsoft JhengHei"/>
+                <a:ea typeface="Microsoft JhengHei"/>
+                <a:cs typeface="Microsoft JhengHei"/>
+              </a:rPr>
+              <a:t>Key Features</a:t>
+            </a:r>
+          </a:p>
+        </p:txBody>
+      </p:sp>
+      <p:sp>
+        <p:nvSpPr>
+          <p:cNvPr id="5" name="TextBox 4"/>
+          <p:cNvSpPr txBox="1"/>
+          <p:nvPr/>
+        </p:nvSpPr>
+        <p:spPr>
+          <a:xfrm>
+            <a:off x="10972800" y="457200"/>
+            <a:ext cx="822960" cy="548640"/>
+          </a:xfrm>
+          <a:prstGeom prst="rect">
+            <a:avLst/>
+          </a:prstGeom>
+          <a:noFill/>
+        </p:spPr>
+        <p:txBody>
+          <a:bodyPr wrap="square" anchor="t">
+            <a:spAutoFit/>
+          </a:bodyPr>
+          <a:lstStyle/>
+          <a:p>
+            <a:pPr algn="r">
+              <a:lnSpc>
+                <a:spcPct val="105000"/>
+              </a:lnSpc>
+              <a:spcBef>
+                <a:spcPts val="0"/>
+              </a:spcBef>
+              <a:spcAft>
+                <a:spcPts val="200"/>
+              </a:spcAft>
+            </a:pPr>
+            <a:r>
+              <a:rPr sz="1200" b="1">
+                <a:solidFill>
+                  <a:srgbClr val="71717A"/>
+                </a:solidFill>
+                <a:latin typeface="Microsoft JhengHei"/>
+                <a:ea typeface="Microsoft JhengHei"/>
+                <a:cs typeface="Microsoft JhengHei"/>
+              </a:rPr>
+              <a:t>2/3</a:t>
+            </a:r>
+          </a:p>
+        </p:txBody>
+      </p:sp>
+      <p:sp>
+        <p:nvSpPr>
+          <p:cNvPr id="6" name="TextBox 5"/>
+          <p:cNvSpPr txBox="1"/>
+          <p:nvPr/>
+        </p:nvSpPr>
+        <p:spPr>
+          <a:xfrm>
+            <a:off x="640080" y="1417320"/>
+            <a:ext cx="5394960" cy="365760"/>
+          </a:xfrm>
+          <a:prstGeom prst="rect">
+            <a:avLst/>
+          </a:prstGeom>
+          <a:noFill/>
+        </p:spPr>
+        <p:txBody>
+          <a:bodyPr wrap="square" anchor="t">
+            <a:spAutoFit/>
+          </a:bodyPr>
+          <a:lstStyle/>
+          <a:p>
+            <a:pPr algn="l">
+              <a:lnSpc>
+                <a:spcPct val="105000"/>
+              </a:lnSpc>
+              <a:spcBef>
+                <a:spcPts val="0"/>
+              </a:spcBef>
+              <a:spcAft>
+                <a:spcPts val="200"/>
+              </a:spcAft>
+            </a:pPr>
+            <a:r>
               <a:rPr sz="1500" b="1">
                 <a:solidFill>
                   <a:srgbClr val="2563EB"/>
@@ -5688,7 +6085,7 @@
 </p:sld>
 </file>
 
-<file path=ppt/slides/slide3.xml><?xml version="1.0" encoding="utf-8"?>
+<file path=ppt/slides/slide4.xml><?xml version="1.0" encoding="utf-8"?>
 <p:sld xmlns:a="http://schemas.openxmlformats.org/drawingml/2006/main" xmlns:p="http://schemas.openxmlformats.org/presentationml/2006/main" xmlns:r="http://schemas.openxmlformats.org/officeDocument/2006/relationships">
   <p:cSld>
     <p:spTree>

</xml_diff>